<commit_message>
fix(pptx): replace -apple-system with Aptos in template
The template shipped with typeface="-apple-system" on every slide —
that's a CSS font-stack value, not a PowerPoint typeface. macOS Office
silently resolves it to San Francisco; Windows Office can't and falls
back to a font with broken glyph mapping (the symbol-soup TOC slide).

Aptos is Microsoft's current Office default (formerly Bierstadt),
shipped via M365 cloud fonts. 540 typeface replacements across all
17 slide XML files. Layouts/masters untouched. e2e test passes.

Co-Authored-By: Claude Opus 4.7 <noreply@anthropic.com>
</commit_message>
<xml_diff>
--- a/templates/anbudsmall-v2.pptx
+++ b/templates/anbudsmall-v2.pptx
@@ -2216,9 +2216,9 @@
                 <a:solidFill>
                   <a:srgbClr val="1A1A1A"/>
                 </a:solidFill>
-                <a:latin typeface="-apple-system" pitchFamily="34" charset="0"/>
-                <a:ea typeface="-apple-system" pitchFamily="34" charset="-122"/>
-                <a:cs typeface="-apple-system" pitchFamily="34" charset="-120"/>
+                <a:latin typeface="Aptos" pitchFamily="34" charset="0"/>
+                <a:ea typeface="Aptos" pitchFamily="34" charset="-122"/>
+                <a:cs typeface="Aptos" pitchFamily="34" charset="-120"/>
               </a:rPr>
               <a:t>{Kundnamn}</a:t>
             </a:r>
@@ -2260,9 +2260,9 @@
                 <a:solidFill>
                   <a:srgbClr val="2B2B2B"/>
                 </a:solidFill>
-                <a:latin typeface="-apple-system" pitchFamily="34" charset="0"/>
-                <a:ea typeface="-apple-system" pitchFamily="34" charset="-122"/>
-                <a:cs typeface="-apple-system" pitchFamily="34" charset="-120"/>
+                <a:latin typeface="Aptos" pitchFamily="34" charset="0"/>
+                <a:ea typeface="Aptos" pitchFamily="34" charset="-122"/>
+                <a:cs typeface="Aptos" pitchFamily="34" charset="-120"/>
               </a:rPr>
               <a:t>{Upphandlingens namn}</a:t>
             </a:r>
@@ -2607,9 +2607,9 @@
                 <a:solidFill>
                   <a:srgbClr val="4A4A4A"/>
                 </a:solidFill>
-                <a:latin typeface="-apple-system" pitchFamily="34" charset="0"/>
-                <a:ea typeface="-apple-system" pitchFamily="34" charset="-122"/>
-                <a:cs typeface="-apple-system" pitchFamily="34" charset="-120"/>
+                <a:latin typeface="Aptos" pitchFamily="34" charset="0"/>
+                <a:ea typeface="Aptos" pitchFamily="34" charset="-122"/>
+                <a:cs typeface="Aptos" pitchFamily="34" charset="-120"/>
               </a:rPr>
               <a:t>10 · GENOMFÖRANDE — FAS 4 AV 4</a:t>
             </a:r>
@@ -2678,9 +2678,9 @@
                 <a:solidFill>
                   <a:srgbClr val="2B5F5F"/>
                 </a:solidFill>
-                <a:latin typeface="-apple-system" pitchFamily="34" charset="0"/>
-                <a:ea typeface="-apple-system" pitchFamily="34" charset="-122"/>
-                <a:cs typeface="-apple-system" pitchFamily="34" charset="-120"/>
+                <a:latin typeface="Aptos" pitchFamily="34" charset="0"/>
+                <a:ea typeface="Aptos" pitchFamily="34" charset="-122"/>
+                <a:cs typeface="Aptos" pitchFamily="34" charset="-120"/>
               </a:rPr>
               <a:t>04</a:t>
             </a:r>
@@ -2763,9 +2763,9 @@
                 <a:solidFill>
                   <a:srgbClr val="1A1A1A"/>
                 </a:solidFill>
-                <a:latin typeface="-apple-system" pitchFamily="34" charset="0"/>
-                <a:ea typeface="-apple-system" pitchFamily="34" charset="-122"/>
-                <a:cs typeface="-apple-system" pitchFamily="34" charset="-120"/>
+                <a:latin typeface="Aptos" pitchFamily="34" charset="0"/>
+                <a:ea typeface="Aptos" pitchFamily="34" charset="-122"/>
+                <a:cs typeface="Aptos" pitchFamily="34" charset="-120"/>
               </a:rPr>
               <a:t>{Fas 4 — namn}</a:t>
             </a:r>
@@ -2927,9 +2927,9 @@
                 <a:solidFill>
                   <a:srgbClr val="1A1A1A"/>
                 </a:solidFill>
-                <a:latin typeface="-apple-system" pitchFamily="34" charset="0"/>
-                <a:ea typeface="-apple-system" pitchFamily="34" charset="-122"/>
-                <a:cs typeface="-apple-system" pitchFamily="34" charset="-120"/>
+                <a:latin typeface="Aptos" pitchFamily="34" charset="0"/>
+                <a:ea typeface="Aptos" pitchFamily="34" charset="-122"/>
+                <a:cs typeface="Aptos" pitchFamily="34" charset="-120"/>
               </a:rPr>
               <a:t>{Aktivitet 1}</a:t>
             </a:r>
@@ -2971,9 +2971,9 @@
                 <a:solidFill>
                   <a:srgbClr val="1A1A1A"/>
                 </a:solidFill>
-                <a:latin typeface="-apple-system" pitchFamily="34" charset="0"/>
-                <a:ea typeface="-apple-system" pitchFamily="34" charset="-122"/>
-                <a:cs typeface="-apple-system" pitchFamily="34" charset="-120"/>
+                <a:latin typeface="Aptos" pitchFamily="34" charset="0"/>
+                <a:ea typeface="Aptos" pitchFamily="34" charset="-122"/>
+                <a:cs typeface="Aptos" pitchFamily="34" charset="-120"/>
               </a:rPr>
               <a:t>{Aktivitet 2}</a:t>
             </a:r>
@@ -3015,9 +3015,9 @@
                 <a:solidFill>
                   <a:srgbClr val="1A1A1A"/>
                 </a:solidFill>
-                <a:latin typeface="-apple-system" pitchFamily="34" charset="0"/>
-                <a:ea typeface="-apple-system" pitchFamily="34" charset="-122"/>
-                <a:cs typeface="-apple-system" pitchFamily="34" charset="-120"/>
+                <a:latin typeface="Aptos" pitchFamily="34" charset="0"/>
+                <a:ea typeface="Aptos" pitchFamily="34" charset="-122"/>
+                <a:cs typeface="Aptos" pitchFamily="34" charset="-120"/>
               </a:rPr>
               <a:t>{Aktivitet 3}</a:t>
             </a:r>
@@ -3059,9 +3059,9 @@
                 <a:solidFill>
                   <a:srgbClr val="1A1A1A"/>
                 </a:solidFill>
-                <a:latin typeface="-apple-system" pitchFamily="34" charset="0"/>
-                <a:ea typeface="-apple-system" pitchFamily="34" charset="-122"/>
-                <a:cs typeface="-apple-system" pitchFamily="34" charset="-120"/>
+                <a:latin typeface="Aptos" pitchFamily="34" charset="0"/>
+                <a:ea typeface="Aptos" pitchFamily="34" charset="-122"/>
+                <a:cs typeface="Aptos" pitchFamily="34" charset="-120"/>
               </a:rPr>
               <a:t>{Aktivitet 4}</a:t>
             </a:r>
@@ -3182,9 +3182,9 @@
                 <a:solidFill>
                   <a:srgbClr val="1A1A1A"/>
                 </a:solidFill>
-                <a:latin typeface="-apple-system" pitchFamily="34" charset="0"/>
-                <a:ea typeface="-apple-system" pitchFamily="34" charset="-122"/>
-                <a:cs typeface="-apple-system" pitchFamily="34" charset="-120"/>
+                <a:latin typeface="Aptos" pitchFamily="34" charset="0"/>
+                <a:ea typeface="Aptos" pitchFamily="34" charset="-122"/>
+                <a:cs typeface="Aptos" pitchFamily="34" charset="-120"/>
               </a:rPr>
               <a:t>{Leverans 1 — slutleverans}</a:t>
             </a:r>
@@ -3226,9 +3226,9 @@
                 <a:solidFill>
                   <a:srgbClr val="1A1A1A"/>
                 </a:solidFill>
-                <a:latin typeface="-apple-system" pitchFamily="34" charset="0"/>
-                <a:ea typeface="-apple-system" pitchFamily="34" charset="-122"/>
-                <a:cs typeface="-apple-system" pitchFamily="34" charset="-120"/>
+                <a:latin typeface="Aptos" pitchFamily="34" charset="0"/>
+                <a:ea typeface="Aptos" pitchFamily="34" charset="-122"/>
+                <a:cs typeface="Aptos" pitchFamily="34" charset="-120"/>
               </a:rPr>
               <a:t>{Leverans 2 — överlämning}</a:t>
             </a:r>
@@ -3270,9 +3270,9 @@
                 <a:solidFill>
                   <a:srgbClr val="1A1A1A"/>
                 </a:solidFill>
-                <a:latin typeface="-apple-system" pitchFamily="34" charset="0"/>
-                <a:ea typeface="-apple-system" pitchFamily="34" charset="-122"/>
-                <a:cs typeface="-apple-system" pitchFamily="34" charset="-120"/>
+                <a:latin typeface="Aptos" pitchFamily="34" charset="0"/>
+                <a:ea typeface="Aptos" pitchFamily="34" charset="-122"/>
+                <a:cs typeface="Aptos" pitchFamily="34" charset="-120"/>
               </a:rPr>
               <a:t>{Leverans 3 — slutrapport}</a:t>
             </a:r>
@@ -3420,9 +3420,9 @@
                 <a:solidFill>
                   <a:srgbClr val="1A1A1A"/>
                 </a:solidFill>
-                <a:latin typeface="-apple-system" pitchFamily="34" charset="0"/>
-                <a:ea typeface="-apple-system" pitchFamily="34" charset="-122"/>
-                <a:cs typeface="-apple-system" pitchFamily="34" charset="-120"/>
+                <a:latin typeface="Aptos" pitchFamily="34" charset="0"/>
+                <a:ea typeface="Aptos" pitchFamily="34" charset="-122"/>
+                <a:cs typeface="Aptos" pitchFamily="34" charset="-120"/>
               </a:rPr>
               <a:t>{Beslut 1 — godkännande av slutleverans}</a:t>
             </a:r>
@@ -3464,9 +3464,9 @@
                 <a:solidFill>
                   <a:srgbClr val="1A1A1A"/>
                 </a:solidFill>
-                <a:latin typeface="-apple-system" pitchFamily="34" charset="0"/>
-                <a:ea typeface="-apple-system" pitchFamily="34" charset="-122"/>
-                <a:cs typeface="-apple-system" pitchFamily="34" charset="-120"/>
+                <a:latin typeface="Aptos" pitchFamily="34" charset="0"/>
+                <a:ea typeface="Aptos" pitchFamily="34" charset="-122"/>
+                <a:cs typeface="Aptos" pitchFamily="34" charset="-120"/>
               </a:rPr>
               <a:t>{Beslut 2 — förvaltningsöverlämning}</a:t>
             </a:r>
@@ -3508,9 +3508,9 @@
                 <a:solidFill>
                   <a:srgbClr val="1A1A1A"/>
                 </a:solidFill>
-                <a:latin typeface="-apple-system" pitchFamily="34" charset="0"/>
-                <a:ea typeface="-apple-system" pitchFamily="34" charset="-122"/>
-                <a:cs typeface="-apple-system" pitchFamily="34" charset="-120"/>
+                <a:latin typeface="Aptos" pitchFamily="34" charset="0"/>
+                <a:ea typeface="Aptos" pitchFamily="34" charset="-122"/>
+                <a:cs typeface="Aptos" pitchFamily="34" charset="-120"/>
               </a:rPr>
               <a:t>{Avslut av uppdrag}</a:t>
             </a:r>
@@ -4651,9 +4651,9 @@
                 <a:solidFill>
                   <a:srgbClr val="4A4A4A"/>
                 </a:solidFill>
-                <a:latin typeface="-apple-system" pitchFamily="34" charset="0"/>
-                <a:ea typeface="-apple-system" pitchFamily="34" charset="-122"/>
-                <a:cs typeface="-apple-system" pitchFamily="34" charset="-120"/>
+                <a:latin typeface="Aptos" pitchFamily="34" charset="0"/>
+                <a:ea typeface="Aptos" pitchFamily="34" charset="-122"/>
+                <a:cs typeface="Aptos" pitchFamily="34" charset="-120"/>
               </a:rPr>
               <a:t>11 · KVALITETSSÄKRING</a:t>
             </a:r>
@@ -4695,9 +4695,9 @@
                 <a:solidFill>
                   <a:srgbClr val="1A1A1A"/>
                 </a:solidFill>
-                <a:latin typeface="-apple-system" pitchFamily="34" charset="0"/>
-                <a:ea typeface="-apple-system" pitchFamily="34" charset="-122"/>
-                <a:cs typeface="-apple-system" pitchFamily="34" charset="-120"/>
+                <a:latin typeface="Aptos" pitchFamily="34" charset="0"/>
+                <a:ea typeface="Aptos" pitchFamily="34" charset="-122"/>
+                <a:cs typeface="Aptos" pitchFamily="34" charset="-120"/>
               </a:rPr>
               <a:t>Kvalitetssäkring</a:t>
             </a:r>
@@ -4818,9 +4818,9 @@
                 <a:solidFill>
                   <a:srgbClr val="4A4A4A"/>
                 </a:solidFill>
-                <a:latin typeface="-apple-system" pitchFamily="34" charset="0"/>
-                <a:ea typeface="-apple-system" pitchFamily="34" charset="-122"/>
-                <a:cs typeface="-apple-system" pitchFamily="34" charset="-120"/>
+                <a:latin typeface="Aptos" pitchFamily="34" charset="0"/>
+                <a:ea typeface="Aptos" pitchFamily="34" charset="-122"/>
+                <a:cs typeface="Aptos" pitchFamily="34" charset="-120"/>
               </a:rPr>
               <a:t>{QA-process}</a:t>
             </a:r>
@@ -4941,9 +4941,9 @@
                 <a:solidFill>
                   <a:srgbClr val="4A4A4A"/>
                 </a:solidFill>
-                <a:latin typeface="-apple-system" pitchFamily="34" charset="0"/>
-                <a:ea typeface="-apple-system" pitchFamily="34" charset="-122"/>
-                <a:cs typeface="-apple-system" pitchFamily="34" charset="-120"/>
+                <a:latin typeface="Aptos" pitchFamily="34" charset="0"/>
+                <a:ea typeface="Aptos" pitchFamily="34" charset="-122"/>
+                <a:cs typeface="Aptos" pitchFamily="34" charset="-120"/>
               </a:rPr>
               <a:t>{Kvalitetsledare}</a:t>
             </a:r>
@@ -5064,9 +5064,9 @@
                 <a:solidFill>
                   <a:srgbClr val="4A4A4A"/>
                 </a:solidFill>
-                <a:latin typeface="-apple-system" pitchFamily="34" charset="0"/>
-                <a:ea typeface="-apple-system" pitchFamily="34" charset="-122"/>
-                <a:cs typeface="-apple-system" pitchFamily="34" charset="-120"/>
+                <a:latin typeface="Aptos" pitchFamily="34" charset="0"/>
+                <a:ea typeface="Aptos" pitchFamily="34" charset="-122"/>
+                <a:cs typeface="Aptos" pitchFamily="34" charset="-120"/>
               </a:rPr>
               <a:t>{Eskalering}</a:t>
             </a:r>
@@ -5249,9 +5249,9 @@
                 <a:solidFill>
                   <a:srgbClr val="4A4A4A"/>
                 </a:solidFill>
-                <a:latin typeface="-apple-system" pitchFamily="34" charset="0"/>
-                <a:ea typeface="-apple-system" pitchFamily="34" charset="-122"/>
-                <a:cs typeface="-apple-system" pitchFamily="34" charset="-120"/>
+                <a:latin typeface="Aptos" pitchFamily="34" charset="0"/>
+                <a:ea typeface="Aptos" pitchFamily="34" charset="-122"/>
+                <a:cs typeface="Aptos" pitchFamily="34" charset="-120"/>
               </a:rPr>
               <a:t>{Avstämning 1 — tidpunkt och innehåll}</a:t>
             </a:r>
@@ -5366,9 +5366,9 @@
                 <a:solidFill>
                   <a:srgbClr val="4A4A4A"/>
                 </a:solidFill>
-                <a:latin typeface="-apple-system" pitchFamily="34" charset="0"/>
-                <a:ea typeface="-apple-system" pitchFamily="34" charset="-122"/>
-                <a:cs typeface="-apple-system" pitchFamily="34" charset="-120"/>
+                <a:latin typeface="Aptos" pitchFamily="34" charset="0"/>
+                <a:ea typeface="Aptos" pitchFamily="34" charset="-122"/>
+                <a:cs typeface="Aptos" pitchFamily="34" charset="-120"/>
               </a:rPr>
               <a:t>{Avstämning 2}</a:t>
             </a:r>
@@ -5483,9 +5483,9 @@
                 <a:solidFill>
                   <a:srgbClr val="4A4A4A"/>
                 </a:solidFill>
-                <a:latin typeface="-apple-system" pitchFamily="34" charset="0"/>
-                <a:ea typeface="-apple-system" pitchFamily="34" charset="-122"/>
-                <a:cs typeface="-apple-system" pitchFamily="34" charset="-120"/>
+                <a:latin typeface="Aptos" pitchFamily="34" charset="0"/>
+                <a:ea typeface="Aptos" pitchFamily="34" charset="-122"/>
+                <a:cs typeface="Aptos" pitchFamily="34" charset="-120"/>
               </a:rPr>
               <a:t>{Avstämning 3}</a:t>
             </a:r>
@@ -5600,9 +5600,9 @@
                 <a:solidFill>
                   <a:srgbClr val="4A4A4A"/>
                 </a:solidFill>
-                <a:latin typeface="-apple-system" pitchFamily="34" charset="0"/>
-                <a:ea typeface="-apple-system" pitchFamily="34" charset="-122"/>
-                <a:cs typeface="-apple-system" pitchFamily="34" charset="-120"/>
+                <a:latin typeface="Aptos" pitchFamily="34" charset="0"/>
+                <a:ea typeface="Aptos" pitchFamily="34" charset="-122"/>
+                <a:cs typeface="Aptos" pitchFamily="34" charset="-120"/>
               </a:rPr>
               <a:t>{Avstämning 4}</a:t>
             </a:r>
@@ -5805,9 +5805,9 @@
                 <a:solidFill>
                   <a:srgbClr val="4A4A4A"/>
                 </a:solidFill>
-                <a:latin typeface="-apple-system" pitchFamily="34" charset="0"/>
-                <a:ea typeface="-apple-system" pitchFamily="34" charset="-122"/>
-                <a:cs typeface="-apple-system" pitchFamily="34" charset="-120"/>
+                <a:latin typeface="Aptos" pitchFamily="34" charset="0"/>
+                <a:ea typeface="Aptos" pitchFamily="34" charset="-122"/>
+                <a:cs typeface="Aptos" pitchFamily="34" charset="-120"/>
               </a:rPr>
               <a:t>12 · TEAM, OMFATTNING OCH PRIS</a:t>
             </a:r>
@@ -5849,9 +5849,9 @@
                 <a:solidFill>
                   <a:srgbClr val="1A1A1A"/>
                 </a:solidFill>
-                <a:latin typeface="-apple-system" pitchFamily="34" charset="0"/>
-                <a:ea typeface="-apple-system" pitchFamily="34" charset="-122"/>
-                <a:cs typeface="-apple-system" pitchFamily="34" charset="-120"/>
+                <a:latin typeface="Aptos" pitchFamily="34" charset="0"/>
+                <a:ea typeface="Aptos" pitchFamily="34" charset="-122"/>
+                <a:cs typeface="Aptos" pitchFamily="34" charset="-120"/>
               </a:rPr>
               <a:t>Team, omfattning och pris</a:t>
             </a:r>
@@ -6670,9 +6670,9 @@
                 <a:solidFill>
                   <a:srgbClr val="1A1A1A"/>
                 </a:solidFill>
-                <a:latin typeface="-apple-system" pitchFamily="34" charset="0"/>
-                <a:ea typeface="-apple-system" pitchFamily="34" charset="-122"/>
-                <a:cs typeface="-apple-system" pitchFamily="34" charset="-120"/>
+                <a:latin typeface="Aptos" pitchFamily="34" charset="0"/>
+                <a:ea typeface="Aptos" pitchFamily="34" charset="-122"/>
+                <a:cs typeface="Aptos" pitchFamily="34" charset="-120"/>
               </a:rPr>
               <a:t>{Konsult 1 — namn}</a:t>
             </a:r>
@@ -6714,9 +6714,9 @@
                 <a:solidFill>
                   <a:srgbClr val="4A4A4A"/>
                 </a:solidFill>
-                <a:latin typeface="-apple-system" pitchFamily="34" charset="0"/>
-                <a:ea typeface="-apple-system" pitchFamily="34" charset="-122"/>
-                <a:cs typeface="-apple-system" pitchFamily="34" charset="-120"/>
+                <a:latin typeface="Aptos" pitchFamily="34" charset="0"/>
+                <a:ea typeface="Aptos" pitchFamily="34" charset="-122"/>
+                <a:cs typeface="Aptos" pitchFamily="34" charset="-120"/>
               </a:rPr>
               <a:t>{Roll 1}</a:t>
             </a:r>
@@ -6961,9 +6961,9 @@
                 <a:solidFill>
                   <a:srgbClr val="1A1A1A"/>
                 </a:solidFill>
-                <a:latin typeface="-apple-system" pitchFamily="34" charset="0"/>
-                <a:ea typeface="-apple-system" pitchFamily="34" charset="-122"/>
-                <a:cs typeface="-apple-system" pitchFamily="34" charset="-120"/>
+                <a:latin typeface="Aptos" pitchFamily="34" charset="0"/>
+                <a:ea typeface="Aptos" pitchFamily="34" charset="-122"/>
+                <a:cs typeface="Aptos" pitchFamily="34" charset="-120"/>
               </a:rPr>
               <a:t>{Konsult 2 — namn}</a:t>
             </a:r>
@@ -7005,9 +7005,9 @@
                 <a:solidFill>
                   <a:srgbClr val="4A4A4A"/>
                 </a:solidFill>
-                <a:latin typeface="-apple-system" pitchFamily="34" charset="0"/>
-                <a:ea typeface="-apple-system" pitchFamily="34" charset="-122"/>
-                <a:cs typeface="-apple-system" pitchFamily="34" charset="-120"/>
+                <a:latin typeface="Aptos" pitchFamily="34" charset="0"/>
+                <a:ea typeface="Aptos" pitchFamily="34" charset="-122"/>
+                <a:cs typeface="Aptos" pitchFamily="34" charset="-120"/>
               </a:rPr>
               <a:t>{Roll 2}</a:t>
             </a:r>
@@ -7252,9 +7252,9 @@
                 <a:solidFill>
                   <a:srgbClr val="1A1A1A"/>
                 </a:solidFill>
-                <a:latin typeface="-apple-system" pitchFamily="34" charset="0"/>
-                <a:ea typeface="-apple-system" pitchFamily="34" charset="-122"/>
-                <a:cs typeface="-apple-system" pitchFamily="34" charset="-120"/>
+                <a:latin typeface="Aptos" pitchFamily="34" charset="0"/>
+                <a:ea typeface="Aptos" pitchFamily="34" charset="-122"/>
+                <a:cs typeface="Aptos" pitchFamily="34" charset="-120"/>
               </a:rPr>
               <a:t>{Konsult 3 — namn}</a:t>
             </a:r>
@@ -7296,9 +7296,9 @@
                 <a:solidFill>
                   <a:srgbClr val="4A4A4A"/>
                 </a:solidFill>
-                <a:latin typeface="-apple-system" pitchFamily="34" charset="0"/>
-                <a:ea typeface="-apple-system" pitchFamily="34" charset="-122"/>
-                <a:cs typeface="-apple-system" pitchFamily="34" charset="-120"/>
+                <a:latin typeface="Aptos" pitchFamily="34" charset="0"/>
+                <a:ea typeface="Aptos" pitchFamily="34" charset="-122"/>
+                <a:cs typeface="Aptos" pitchFamily="34" charset="-120"/>
               </a:rPr>
               <a:t>{Roll 3}</a:t>
             </a:r>
@@ -7543,9 +7543,9 @@
                 <a:solidFill>
                   <a:srgbClr val="1A1A1A"/>
                 </a:solidFill>
-                <a:latin typeface="-apple-system" pitchFamily="34" charset="0"/>
-                <a:ea typeface="-apple-system" pitchFamily="34" charset="-122"/>
-                <a:cs typeface="-apple-system" pitchFamily="34" charset="-120"/>
+                <a:latin typeface="Aptos" pitchFamily="34" charset="0"/>
+                <a:ea typeface="Aptos" pitchFamily="34" charset="-122"/>
+                <a:cs typeface="Aptos" pitchFamily="34" charset="-120"/>
               </a:rPr>
               <a:t>{Konsult 4 — namn}</a:t>
             </a:r>
@@ -7587,9 +7587,9 @@
                 <a:solidFill>
                   <a:srgbClr val="4A4A4A"/>
                 </a:solidFill>
-                <a:latin typeface="-apple-system" pitchFamily="34" charset="0"/>
-                <a:ea typeface="-apple-system" pitchFamily="34" charset="-122"/>
-                <a:cs typeface="-apple-system" pitchFamily="34" charset="-120"/>
+                <a:latin typeface="Aptos" pitchFamily="34" charset="0"/>
+                <a:ea typeface="Aptos" pitchFamily="34" charset="-122"/>
+                <a:cs typeface="Aptos" pitchFamily="34" charset="-120"/>
               </a:rPr>
               <a:t>{Roll 4}</a:t>
             </a:r>
@@ -7834,9 +7834,9 @@
                 <a:solidFill>
                   <a:srgbClr val="1A1A1A"/>
                 </a:solidFill>
-                <a:latin typeface="-apple-system" pitchFamily="34" charset="0"/>
-                <a:ea typeface="-apple-system" pitchFamily="34" charset="-122"/>
-                <a:cs typeface="-apple-system" pitchFamily="34" charset="-120"/>
+                <a:latin typeface="Aptos" pitchFamily="34" charset="0"/>
+                <a:ea typeface="Aptos" pitchFamily="34" charset="-122"/>
+                <a:cs typeface="Aptos" pitchFamily="34" charset="-120"/>
               </a:rPr>
               <a:t>{Konsult 5 — namn}</a:t>
             </a:r>
@@ -7878,9 +7878,9 @@
                 <a:solidFill>
                   <a:srgbClr val="4A4A4A"/>
                 </a:solidFill>
-                <a:latin typeface="-apple-system" pitchFamily="34" charset="0"/>
-                <a:ea typeface="-apple-system" pitchFamily="34" charset="-122"/>
-                <a:cs typeface="-apple-system" pitchFamily="34" charset="-120"/>
+                <a:latin typeface="Aptos" pitchFamily="34" charset="0"/>
+                <a:ea typeface="Aptos" pitchFamily="34" charset="-122"/>
+                <a:cs typeface="Aptos" pitchFamily="34" charset="-120"/>
               </a:rPr>
               <a:t>{Roll 5}</a:t>
             </a:r>
@@ -8152,9 +8152,9 @@
                 <a:solidFill>
                   <a:srgbClr val="1A1A1A"/>
                 </a:solidFill>
-                <a:latin typeface="-apple-system" pitchFamily="34" charset="0"/>
-                <a:ea typeface="-apple-system" pitchFamily="34" charset="-122"/>
-                <a:cs typeface="-apple-system" pitchFamily="34" charset="-120"/>
+                <a:latin typeface="Aptos" pitchFamily="34" charset="0"/>
+                <a:ea typeface="Aptos" pitchFamily="34" charset="-122"/>
+                <a:cs typeface="Aptos" pitchFamily="34" charset="-120"/>
               </a:rPr>
               <a:t>Summa — anbudspris exkl. moms</a:t>
             </a:r>
@@ -8540,9 +8540,9 @@
                 <a:solidFill>
                   <a:srgbClr val="4A4A4A"/>
                 </a:solidFill>
-                <a:latin typeface="-apple-system" pitchFamily="34" charset="0"/>
-                <a:ea typeface="-apple-system" pitchFamily="34" charset="-122"/>
-                <a:cs typeface="-apple-system" pitchFamily="34" charset="-120"/>
+                <a:latin typeface="Aptos" pitchFamily="34" charset="0"/>
+                <a:ea typeface="Aptos" pitchFamily="34" charset="-122"/>
+                <a:cs typeface="Aptos" pitchFamily="34" charset="-120"/>
               </a:rPr>
               <a:t>13 · UPPFYLLELSE</a:t>
             </a:r>
@@ -8584,9 +8584,9 @@
                 <a:solidFill>
                   <a:srgbClr val="1A1A1A"/>
                 </a:solidFill>
-                <a:latin typeface="-apple-system" pitchFamily="34" charset="0"/>
-                <a:ea typeface="-apple-system" pitchFamily="34" charset="-122"/>
-                <a:cs typeface="-apple-system" pitchFamily="34" charset="-120"/>
+                <a:latin typeface="Aptos" pitchFamily="34" charset="0"/>
+                <a:ea typeface="Aptos" pitchFamily="34" charset="-122"/>
+                <a:cs typeface="Aptos" pitchFamily="34" charset="-120"/>
               </a:rPr>
               <a:t>Uppfyllelse av ska-krav</a:t>
             </a:r>
@@ -9324,9 +9324,9 @@
                 <a:solidFill>
                   <a:srgbClr val="4A4A4A"/>
                 </a:solidFill>
-                <a:latin typeface="-apple-system" pitchFamily="34" charset="0"/>
-                <a:ea typeface="-apple-system" pitchFamily="34" charset="-122"/>
-                <a:cs typeface="-apple-system" pitchFamily="34" charset="-120"/>
+                <a:latin typeface="Aptos" pitchFamily="34" charset="0"/>
+                <a:ea typeface="Aptos" pitchFamily="34" charset="-122"/>
+                <a:cs typeface="Aptos" pitchFamily="34" charset="-120"/>
               </a:rPr>
               <a:t>{Ska-krav 1 — formulering enligt upphandlingsunderlag}</a:t>
             </a:r>
@@ -9441,9 +9441,9 @@
                 <a:solidFill>
                   <a:srgbClr val="4A4A4A"/>
                 </a:solidFill>
-                <a:latin typeface="-apple-system" pitchFamily="34" charset="0"/>
-                <a:ea typeface="-apple-system" pitchFamily="34" charset="-122"/>
-                <a:cs typeface="-apple-system" pitchFamily="34" charset="-120"/>
+                <a:latin typeface="Aptos" pitchFamily="34" charset="0"/>
+                <a:ea typeface="Aptos" pitchFamily="34" charset="-122"/>
+                <a:cs typeface="Aptos" pitchFamily="34" charset="-120"/>
               </a:rPr>
               <a:t>{Hur krav 1 uppfylls — konkret beskrivning}</a:t>
             </a:r>
@@ -9485,9 +9485,9 @@
                 <a:solidFill>
                   <a:srgbClr val="4A4A4A"/>
                 </a:solidFill>
-                <a:latin typeface="-apple-system" pitchFamily="34" charset="0"/>
-                <a:ea typeface="-apple-system" pitchFamily="34" charset="-122"/>
-                <a:cs typeface="-apple-system" pitchFamily="34" charset="-120"/>
+                <a:latin typeface="Aptos" pitchFamily="34" charset="0"/>
+                <a:ea typeface="Aptos" pitchFamily="34" charset="-122"/>
+                <a:cs typeface="Aptos" pitchFamily="34" charset="-120"/>
               </a:rPr>
               <a:t>{CV/ref 1}</a:t>
             </a:r>
@@ -9600,9 +9600,9 @@
                 <a:solidFill>
                   <a:srgbClr val="4A4A4A"/>
                 </a:solidFill>
-                <a:latin typeface="-apple-system" pitchFamily="34" charset="0"/>
-                <a:ea typeface="-apple-system" pitchFamily="34" charset="-122"/>
-                <a:cs typeface="-apple-system" pitchFamily="34" charset="-120"/>
+                <a:latin typeface="Aptos" pitchFamily="34" charset="0"/>
+                <a:ea typeface="Aptos" pitchFamily="34" charset="-122"/>
+                <a:cs typeface="Aptos" pitchFamily="34" charset="-120"/>
               </a:rPr>
               <a:t>{Ska-krav 2}</a:t>
             </a:r>
@@ -9717,9 +9717,9 @@
                 <a:solidFill>
                   <a:srgbClr val="4A4A4A"/>
                 </a:solidFill>
-                <a:latin typeface="-apple-system" pitchFamily="34" charset="0"/>
-                <a:ea typeface="-apple-system" pitchFamily="34" charset="-122"/>
-                <a:cs typeface="-apple-system" pitchFamily="34" charset="-120"/>
+                <a:latin typeface="Aptos" pitchFamily="34" charset="0"/>
+                <a:ea typeface="Aptos" pitchFamily="34" charset="-122"/>
+                <a:cs typeface="Aptos" pitchFamily="34" charset="-120"/>
               </a:rPr>
               <a:t>{Hur krav 2 uppfylls}</a:t>
             </a:r>
@@ -9761,9 +9761,9 @@
                 <a:solidFill>
                   <a:srgbClr val="4A4A4A"/>
                 </a:solidFill>
-                <a:latin typeface="-apple-system" pitchFamily="34" charset="0"/>
-                <a:ea typeface="-apple-system" pitchFamily="34" charset="-122"/>
-                <a:cs typeface="-apple-system" pitchFamily="34" charset="-120"/>
+                <a:latin typeface="Aptos" pitchFamily="34" charset="0"/>
+                <a:ea typeface="Aptos" pitchFamily="34" charset="-122"/>
+                <a:cs typeface="Aptos" pitchFamily="34" charset="-120"/>
               </a:rPr>
               <a:t>{CV/ref 2}</a:t>
             </a:r>
@@ -9876,9 +9876,9 @@
                 <a:solidFill>
                   <a:srgbClr val="4A4A4A"/>
                 </a:solidFill>
-                <a:latin typeface="-apple-system" pitchFamily="34" charset="0"/>
-                <a:ea typeface="-apple-system" pitchFamily="34" charset="-122"/>
-                <a:cs typeface="-apple-system" pitchFamily="34" charset="-120"/>
+                <a:latin typeface="Aptos" pitchFamily="34" charset="0"/>
+                <a:ea typeface="Aptos" pitchFamily="34" charset="-122"/>
+                <a:cs typeface="Aptos" pitchFamily="34" charset="-120"/>
               </a:rPr>
               <a:t>{Ska-krav 3}</a:t>
             </a:r>
@@ -9993,9 +9993,9 @@
                 <a:solidFill>
                   <a:srgbClr val="4A4A4A"/>
                 </a:solidFill>
-                <a:latin typeface="-apple-system" pitchFamily="34" charset="0"/>
-                <a:ea typeface="-apple-system" pitchFamily="34" charset="-122"/>
-                <a:cs typeface="-apple-system" pitchFamily="34" charset="-120"/>
+                <a:latin typeface="Aptos" pitchFamily="34" charset="0"/>
+                <a:ea typeface="Aptos" pitchFamily="34" charset="-122"/>
+                <a:cs typeface="Aptos" pitchFamily="34" charset="-120"/>
               </a:rPr>
               <a:t>{Hur krav 3 uppfylls}</a:t>
             </a:r>
@@ -10037,9 +10037,9 @@
                 <a:solidFill>
                   <a:srgbClr val="4A4A4A"/>
                 </a:solidFill>
-                <a:latin typeface="-apple-system" pitchFamily="34" charset="0"/>
-                <a:ea typeface="-apple-system" pitchFamily="34" charset="-122"/>
-                <a:cs typeface="-apple-system" pitchFamily="34" charset="-120"/>
+                <a:latin typeface="Aptos" pitchFamily="34" charset="0"/>
+                <a:ea typeface="Aptos" pitchFamily="34" charset="-122"/>
+                <a:cs typeface="Aptos" pitchFamily="34" charset="-120"/>
               </a:rPr>
               <a:t>{CV/ref 3}</a:t>
             </a:r>
@@ -10152,9 +10152,9 @@
                 <a:solidFill>
                   <a:srgbClr val="4A4A4A"/>
                 </a:solidFill>
-                <a:latin typeface="-apple-system" pitchFamily="34" charset="0"/>
-                <a:ea typeface="-apple-system" pitchFamily="34" charset="-122"/>
-                <a:cs typeface="-apple-system" pitchFamily="34" charset="-120"/>
+                <a:latin typeface="Aptos" pitchFamily="34" charset="0"/>
+                <a:ea typeface="Aptos" pitchFamily="34" charset="-122"/>
+                <a:cs typeface="Aptos" pitchFamily="34" charset="-120"/>
               </a:rPr>
               <a:t>{Ska-krav 4}</a:t>
             </a:r>
@@ -10269,9 +10269,9 @@
                 <a:solidFill>
                   <a:srgbClr val="4A4A4A"/>
                 </a:solidFill>
-                <a:latin typeface="-apple-system" pitchFamily="34" charset="0"/>
-                <a:ea typeface="-apple-system" pitchFamily="34" charset="-122"/>
-                <a:cs typeface="-apple-system" pitchFamily="34" charset="-120"/>
+                <a:latin typeface="Aptos" pitchFamily="34" charset="0"/>
+                <a:ea typeface="Aptos" pitchFamily="34" charset="-122"/>
+                <a:cs typeface="Aptos" pitchFamily="34" charset="-120"/>
               </a:rPr>
               <a:t>{Hur krav 4 uppfylls}</a:t>
             </a:r>
@@ -10313,9 +10313,9 @@
                 <a:solidFill>
                   <a:srgbClr val="4A4A4A"/>
                 </a:solidFill>
-                <a:latin typeface="-apple-system" pitchFamily="34" charset="0"/>
-                <a:ea typeface="-apple-system" pitchFamily="34" charset="-122"/>
-                <a:cs typeface="-apple-system" pitchFamily="34" charset="-120"/>
+                <a:latin typeface="Aptos" pitchFamily="34" charset="0"/>
+                <a:ea typeface="Aptos" pitchFamily="34" charset="-122"/>
+                <a:cs typeface="Aptos" pitchFamily="34" charset="-120"/>
               </a:rPr>
               <a:t>{CV/ref 4}</a:t>
             </a:r>
@@ -10428,9 +10428,9 @@
                 <a:solidFill>
                   <a:srgbClr val="4A4A4A"/>
                 </a:solidFill>
-                <a:latin typeface="-apple-system" pitchFamily="34" charset="0"/>
-                <a:ea typeface="-apple-system" pitchFamily="34" charset="-122"/>
-                <a:cs typeface="-apple-system" pitchFamily="34" charset="-120"/>
+                <a:latin typeface="Aptos" pitchFamily="34" charset="0"/>
+                <a:ea typeface="Aptos" pitchFamily="34" charset="-122"/>
+                <a:cs typeface="Aptos" pitchFamily="34" charset="-120"/>
               </a:rPr>
               <a:t>{Ska-krav 5}</a:t>
             </a:r>
@@ -10545,9 +10545,9 @@
                 <a:solidFill>
                   <a:srgbClr val="4A4A4A"/>
                 </a:solidFill>
-                <a:latin typeface="-apple-system" pitchFamily="34" charset="0"/>
-                <a:ea typeface="-apple-system" pitchFamily="34" charset="-122"/>
-                <a:cs typeface="-apple-system" pitchFamily="34" charset="-120"/>
+                <a:latin typeface="Aptos" pitchFamily="34" charset="0"/>
+                <a:ea typeface="Aptos" pitchFamily="34" charset="-122"/>
+                <a:cs typeface="Aptos" pitchFamily="34" charset="-120"/>
               </a:rPr>
               <a:t>{Hur krav 5 uppfylls}</a:t>
             </a:r>
@@ -10589,9 +10589,9 @@
                 <a:solidFill>
                   <a:srgbClr val="4A4A4A"/>
                 </a:solidFill>
-                <a:latin typeface="-apple-system" pitchFamily="34" charset="0"/>
-                <a:ea typeface="-apple-system" pitchFamily="34" charset="-122"/>
-                <a:cs typeface="-apple-system" pitchFamily="34" charset="-120"/>
+                <a:latin typeface="Aptos" pitchFamily="34" charset="0"/>
+                <a:ea typeface="Aptos" pitchFamily="34" charset="-122"/>
+                <a:cs typeface="Aptos" pitchFamily="34" charset="-120"/>
               </a:rPr>
               <a:t>{CV/ref 5}</a:t>
             </a:r>
@@ -10704,9 +10704,9 @@
                 <a:solidFill>
                   <a:srgbClr val="4A4A4A"/>
                 </a:solidFill>
-                <a:latin typeface="-apple-system" pitchFamily="34" charset="0"/>
-                <a:ea typeface="-apple-system" pitchFamily="34" charset="-122"/>
-                <a:cs typeface="-apple-system" pitchFamily="34" charset="-120"/>
+                <a:latin typeface="Aptos" pitchFamily="34" charset="0"/>
+                <a:ea typeface="Aptos" pitchFamily="34" charset="-122"/>
+                <a:cs typeface="Aptos" pitchFamily="34" charset="-120"/>
               </a:rPr>
               <a:t>{Ska-krav 6}</a:t>
             </a:r>
@@ -10821,9 +10821,9 @@
                 <a:solidFill>
                   <a:srgbClr val="4A4A4A"/>
                 </a:solidFill>
-                <a:latin typeface="-apple-system" pitchFamily="34" charset="0"/>
-                <a:ea typeface="-apple-system" pitchFamily="34" charset="-122"/>
-                <a:cs typeface="-apple-system" pitchFamily="34" charset="-120"/>
+                <a:latin typeface="Aptos" pitchFamily="34" charset="0"/>
+                <a:ea typeface="Aptos" pitchFamily="34" charset="-122"/>
+                <a:cs typeface="Aptos" pitchFamily="34" charset="-120"/>
               </a:rPr>
               <a:t>{Hur krav 6 uppfylls}</a:t>
             </a:r>
@@ -10865,9 +10865,9 @@
                 <a:solidFill>
                   <a:srgbClr val="4A4A4A"/>
                 </a:solidFill>
-                <a:latin typeface="-apple-system" pitchFamily="34" charset="0"/>
-                <a:ea typeface="-apple-system" pitchFamily="34" charset="-122"/>
-                <a:cs typeface="-apple-system" pitchFamily="34" charset="-120"/>
+                <a:latin typeface="Aptos" pitchFamily="34" charset="0"/>
+                <a:ea typeface="Aptos" pitchFamily="34" charset="-122"/>
+                <a:cs typeface="Aptos" pitchFamily="34" charset="-120"/>
               </a:rPr>
               <a:t>{CV/ref 6}</a:t>
             </a:r>
@@ -11070,9 +11070,9 @@
                 <a:solidFill>
                   <a:srgbClr val="4A4A4A"/>
                 </a:solidFill>
-                <a:latin typeface="-apple-system" pitchFamily="34" charset="0"/>
-                <a:ea typeface="-apple-system" pitchFamily="34" charset="-122"/>
-                <a:cs typeface="-apple-system" pitchFamily="34" charset="-120"/>
+                <a:latin typeface="Aptos" pitchFamily="34" charset="0"/>
+                <a:ea typeface="Aptos" pitchFamily="34" charset="-122"/>
+                <a:cs typeface="Aptos" pitchFamily="34" charset="-120"/>
               </a:rPr>
               <a:t>14 · REFERENS 01</a:t>
             </a:r>
@@ -11114,9 +11114,9 @@
                 <a:solidFill>
                   <a:srgbClr val="4A4A4A"/>
                 </a:solidFill>
-                <a:latin typeface="-apple-system" pitchFamily="34" charset="0"/>
-                <a:ea typeface="-apple-system" pitchFamily="34" charset="-122"/>
-                <a:cs typeface="-apple-system" pitchFamily="34" charset="-120"/>
+                <a:latin typeface="Aptos" pitchFamily="34" charset="0"/>
+                <a:ea typeface="Aptos" pitchFamily="34" charset="-122"/>
+                <a:cs typeface="Aptos" pitchFamily="34" charset="-120"/>
               </a:rPr>
               <a:t>{Referens 1 — kundnamn}</a:t>
             </a:r>
@@ -11158,9 +11158,9 @@
                 <a:solidFill>
                   <a:srgbClr val="4A4A4A"/>
                 </a:solidFill>
-                <a:latin typeface="-apple-system" pitchFamily="34" charset="0"/>
-                <a:ea typeface="-apple-system" pitchFamily="34" charset="-122"/>
-                <a:cs typeface="-apple-system" pitchFamily="34" charset="-120"/>
+                <a:latin typeface="Aptos" pitchFamily="34" charset="0"/>
+                <a:ea typeface="Aptos" pitchFamily="34" charset="-122"/>
+                <a:cs typeface="Aptos" pitchFamily="34" charset="-120"/>
               </a:rPr>
               <a:t>{Referens 1 — kort kontextrad, t.ex. ”Digitalisering av ärendehantering”}</a:t>
             </a:r>
@@ -11229,9 +11229,9 @@
                 <a:solidFill>
                   <a:srgbClr val="1A1A1A"/>
                 </a:solidFill>
-                <a:latin typeface="-apple-system" pitchFamily="34" charset="0"/>
-                <a:ea typeface="-apple-system" pitchFamily="34" charset="-122"/>
-                <a:cs typeface="-apple-system" pitchFamily="34" charset="-120"/>
+                <a:latin typeface="Aptos" pitchFamily="34" charset="0"/>
+                <a:ea typeface="Aptos" pitchFamily="34" charset="-122"/>
+                <a:cs typeface="Aptos" pitchFamily="34" charset="-120"/>
               </a:rPr>
               <a:t>{Vänster}</a:t>
             </a:r>
@@ -11273,9 +11273,9 @@
                 <a:solidFill>
                   <a:srgbClr val="1A1A1A"/>
                 </a:solidFill>
-                <a:latin typeface="-apple-system" pitchFamily="34" charset="0"/>
-                <a:ea typeface="-apple-system" pitchFamily="34" charset="-122"/>
-                <a:cs typeface="-apple-system" pitchFamily="34" charset="-120"/>
+                <a:latin typeface="Aptos" pitchFamily="34" charset="0"/>
+                <a:ea typeface="Aptos" pitchFamily="34" charset="-122"/>
+                <a:cs typeface="Aptos" pitchFamily="34" charset="-120"/>
               </a:rPr>
               <a:t>{Höger}</a:t>
             </a:r>
@@ -11478,9 +11478,9 @@
                 <a:solidFill>
                   <a:srgbClr val="4A4A4A"/>
                 </a:solidFill>
-                <a:latin typeface="-apple-system" pitchFamily="34" charset="0"/>
-                <a:ea typeface="-apple-system" pitchFamily="34" charset="-122"/>
-                <a:cs typeface="-apple-system" pitchFamily="34" charset="-120"/>
+                <a:latin typeface="Aptos" pitchFamily="34" charset="0"/>
+                <a:ea typeface="Aptos" pitchFamily="34" charset="-122"/>
+                <a:cs typeface="Aptos" pitchFamily="34" charset="-120"/>
               </a:rPr>
               <a:t>15 · REFERENS 02</a:t>
             </a:r>
@@ -11522,9 +11522,9 @@
                 <a:solidFill>
                   <a:srgbClr val="4A4A4A"/>
                 </a:solidFill>
-                <a:latin typeface="-apple-system" pitchFamily="34" charset="0"/>
-                <a:ea typeface="-apple-system" pitchFamily="34" charset="-122"/>
-                <a:cs typeface="-apple-system" pitchFamily="34" charset="-120"/>
+                <a:latin typeface="Aptos" pitchFamily="34" charset="0"/>
+                <a:ea typeface="Aptos" pitchFamily="34" charset="-122"/>
+                <a:cs typeface="Aptos" pitchFamily="34" charset="-120"/>
               </a:rPr>
               <a:t>{Referens 2 — kundnamn}</a:t>
             </a:r>
@@ -11566,9 +11566,9 @@
                 <a:solidFill>
                   <a:srgbClr val="4A4A4A"/>
                 </a:solidFill>
-                <a:latin typeface="-apple-system" pitchFamily="34" charset="0"/>
-                <a:ea typeface="-apple-system" pitchFamily="34" charset="-122"/>
-                <a:cs typeface="-apple-system" pitchFamily="34" charset="-120"/>
+                <a:latin typeface="Aptos" pitchFamily="34" charset="0"/>
+                <a:ea typeface="Aptos" pitchFamily="34" charset="-122"/>
+                <a:cs typeface="Aptos" pitchFamily="34" charset="-120"/>
               </a:rPr>
               <a:t>{Referens 2 — kort kontextrad}</a:t>
             </a:r>
@@ -11678,9 +11678,9 @@
                 <a:solidFill>
                   <a:srgbClr val="1A1A1A"/>
                 </a:solidFill>
-                <a:latin typeface="-apple-system" pitchFamily="34" charset="0"/>
-                <a:ea typeface="-apple-system" pitchFamily="34" charset="-122"/>
-                <a:cs typeface="-apple-system" pitchFamily="34" charset="-120"/>
+                <a:latin typeface="Aptos" pitchFamily="34" charset="0"/>
+                <a:ea typeface="Aptos" pitchFamily="34" charset="-122"/>
+                <a:cs typeface="Aptos" pitchFamily="34" charset="-120"/>
               </a:rPr>
               <a:t>{Kund — organisation}</a:t>
             </a:r>
@@ -11848,9 +11848,9 @@
                 <a:solidFill>
                   <a:srgbClr val="1A1A1A"/>
                 </a:solidFill>
-                <a:latin typeface="-apple-system" pitchFamily="34" charset="0"/>
-                <a:ea typeface="-apple-system" pitchFamily="34" charset="-122"/>
-                <a:cs typeface="-apple-system" pitchFamily="34" charset="-120"/>
+                <a:latin typeface="Aptos" pitchFamily="34" charset="0"/>
+                <a:ea typeface="Aptos" pitchFamily="34" charset="-122"/>
+                <a:cs typeface="Aptos" pitchFamily="34" charset="-120"/>
               </a:rPr>
               <a:t>{Omfattning — antal timmar, konsulter och total volym}</a:t>
             </a:r>
@@ -11933,9 +11933,9 @@
                 <a:solidFill>
                   <a:srgbClr val="1A1A1A"/>
                 </a:solidFill>
-                <a:latin typeface="-apple-system" pitchFamily="34" charset="0"/>
-                <a:ea typeface="-apple-system" pitchFamily="34" charset="-122"/>
-                <a:cs typeface="-apple-system" pitchFamily="34" charset="-120"/>
+                <a:latin typeface="Aptos" pitchFamily="34" charset="0"/>
+                <a:ea typeface="Aptos" pitchFamily="34" charset="-122"/>
+                <a:cs typeface="Aptos" pitchFamily="34" charset="-120"/>
               </a:rPr>
               <a:t>{Namn} </a:t>
             </a:r>
@@ -12029,9 +12029,9 @@
                 <a:solidFill>
                   <a:srgbClr val="1A1A1A"/>
                 </a:solidFill>
-                <a:latin typeface="-apple-system" pitchFamily="34" charset="0"/>
-                <a:ea typeface="-apple-system" pitchFamily="34" charset="-122"/>
-                <a:cs typeface="-apple-system" pitchFamily="34" charset="-120"/>
+                <a:latin typeface="Aptos" pitchFamily="34" charset="0"/>
+                <a:ea typeface="Aptos" pitchFamily="34" charset="-122"/>
+                <a:cs typeface="Aptos" pitchFamily="34" charset="-120"/>
               </a:rPr>
               <a:t>{Roll/leverans}</a:t>
             </a:r>
@@ -12114,9 +12114,9 @@
                 <a:solidFill>
                   <a:srgbClr val="1A1A1A"/>
                 </a:solidFill>
-                <a:latin typeface="-apple-system" pitchFamily="34" charset="0"/>
-                <a:ea typeface="-apple-system" pitchFamily="34" charset="-122"/>
-                <a:cs typeface="-apple-system" pitchFamily="34" charset="-120"/>
+                <a:latin typeface="Aptos" pitchFamily="34" charset="0"/>
+                <a:ea typeface="Aptos" pitchFamily="34" charset="-122"/>
+                <a:cs typeface="Aptos" pitchFamily="34" charset="-120"/>
               </a:rPr>
               <a:t>{Resultat}</a:t>
             </a:r>
@@ -12319,9 +12319,9 @@
                 <a:solidFill>
                   <a:srgbClr val="4A4A4A"/>
                 </a:solidFill>
-                <a:latin typeface="-apple-system" pitchFamily="34" charset="0"/>
-                <a:ea typeface="-apple-system" pitchFamily="34" charset="-122"/>
-                <a:cs typeface="-apple-system" pitchFamily="34" charset="-120"/>
+                <a:latin typeface="Aptos" pitchFamily="34" charset="0"/>
+                <a:ea typeface="Aptos" pitchFamily="34" charset="-122"/>
+                <a:cs typeface="Aptos" pitchFamily="34" charset="-120"/>
               </a:rPr>
               <a:t>16 · ANBUDSSEKRETESS</a:t>
             </a:r>
@@ -12363,9 +12363,9 @@
                 <a:solidFill>
                   <a:srgbClr val="1A1A1A"/>
                 </a:solidFill>
-                <a:latin typeface="-apple-system" pitchFamily="34" charset="0"/>
-                <a:ea typeface="-apple-system" pitchFamily="34" charset="-122"/>
-                <a:cs typeface="-apple-system" pitchFamily="34" charset="-120"/>
+                <a:latin typeface="Aptos" pitchFamily="34" charset="0"/>
+                <a:ea typeface="Aptos" pitchFamily="34" charset="-122"/>
+                <a:cs typeface="Aptos" pitchFamily="34" charset="-120"/>
               </a:rPr>
               <a:t>Anbudssekretess</a:t>
             </a:r>
@@ -12407,9 +12407,9 @@
                 <a:solidFill>
                   <a:srgbClr val="4A4A4A"/>
                 </a:solidFill>
-                <a:latin typeface="-apple-system" pitchFamily="34" charset="0"/>
-                <a:ea typeface="-apple-system" pitchFamily="34" charset="-122"/>
-                <a:cs typeface="-apple-system" pitchFamily="34" charset="-120"/>
+                <a:latin typeface="Aptos" pitchFamily="34" charset="0"/>
+                <a:ea typeface="Aptos" pitchFamily="34" charset="-122"/>
+                <a:cs typeface="Aptos" pitchFamily="34" charset="-120"/>
               </a:rPr>
               <a:t>Begäran om sekretess enligt offentlighets- och sekretesslagen</a:t>
             </a:r>
@@ -12451,9 +12451,9 @@
                 <a:solidFill>
                   <a:srgbClr val="4A4A4A"/>
                 </a:solidFill>
-                <a:latin typeface="-apple-system" pitchFamily="34" charset="0"/>
-                <a:ea typeface="-apple-system" pitchFamily="34" charset="-122"/>
-                <a:cs typeface="-apple-system" pitchFamily="34" charset="-120"/>
+                <a:latin typeface="Aptos" pitchFamily="34" charset="0"/>
+                <a:ea typeface="Aptos" pitchFamily="34" charset="-122"/>
+                <a:cs typeface="Aptos" pitchFamily="34" charset="-120"/>
               </a:rPr>
               <a:t>{Bolagsnamn} </a:t>
             </a:r>
@@ -12462,9 +12462,9 @@
                 <a:solidFill>
                   <a:srgbClr val="1A1A1A"/>
                 </a:solidFill>
-                <a:latin typeface="-apple-system" pitchFamily="34" charset="0"/>
-                <a:ea typeface="-apple-system" pitchFamily="34" charset="-122"/>
-                <a:cs typeface="-apple-system" pitchFamily="34" charset="-120"/>
+                <a:latin typeface="Aptos" pitchFamily="34" charset="0"/>
+                <a:ea typeface="Aptos" pitchFamily="34" charset="-122"/>
+                <a:cs typeface="Aptos" pitchFamily="34" charset="-120"/>
               </a:rPr>
               <a:t>begär härmed att följande uppgifter i anbudet omfattas av sekretess enligt </a:t>
             </a:r>
@@ -12473,9 +12473,9 @@
                 <a:solidFill>
                   <a:srgbClr val="4A4A4A"/>
                 </a:solidFill>
-                <a:latin typeface="-apple-system" pitchFamily="34" charset="0"/>
-                <a:ea typeface="-apple-system" pitchFamily="34" charset="-122"/>
-                <a:cs typeface="-apple-system" pitchFamily="34" charset="-120"/>
+                <a:latin typeface="Aptos" pitchFamily="34" charset="0"/>
+                <a:ea typeface="Aptos" pitchFamily="34" charset="-122"/>
+                <a:cs typeface="Aptos" pitchFamily="34" charset="-120"/>
               </a:rPr>
               <a:t>{OSL kap X §Y} </a:t>
             </a:r>
@@ -12484,9 +12484,9 @@
                 <a:solidFill>
                   <a:srgbClr val="1A1A1A"/>
                 </a:solidFill>
-                <a:latin typeface="-apple-system" pitchFamily="34" charset="0"/>
-                <a:ea typeface="-apple-system" pitchFamily="34" charset="-122"/>
-                <a:cs typeface="-apple-system" pitchFamily="34" charset="-120"/>
+                <a:latin typeface="Aptos" pitchFamily="34" charset="0"/>
+                <a:ea typeface="Aptos" pitchFamily="34" charset="-122"/>
+                <a:cs typeface="Aptos" pitchFamily="34" charset="-120"/>
               </a:rPr>
               <a:t>. Ett offentliggörande av nedanstående uppgifter bedöms medföra sådan skada att uppgifterna inte bör lämnas ut.</a:t>
             </a:r>
@@ -12785,9 +12785,9 @@
                 <a:solidFill>
                   <a:srgbClr val="4A4A4A"/>
                 </a:solidFill>
-                <a:latin typeface="-apple-system" pitchFamily="34" charset="0"/>
-                <a:ea typeface="-apple-system" pitchFamily="34" charset="-122"/>
-                <a:cs typeface="-apple-system" pitchFamily="34" charset="-120"/>
+                <a:latin typeface="Aptos" pitchFamily="34" charset="0"/>
+                <a:ea typeface="Aptos" pitchFamily="34" charset="-122"/>
+                <a:cs typeface="Aptos" pitchFamily="34" charset="-120"/>
               </a:rPr>
               <a:t>{Uppgift som omfattas av sekretess}</a:t>
             </a:r>
@@ -12829,9 +12829,9 @@
                 <a:solidFill>
                   <a:srgbClr val="4A4A4A"/>
                 </a:solidFill>
-                <a:latin typeface="-apple-system" pitchFamily="34" charset="0"/>
-                <a:ea typeface="-apple-system" pitchFamily="34" charset="-122"/>
-                <a:cs typeface="-apple-system" pitchFamily="34" charset="-120"/>
+                <a:latin typeface="Aptos" pitchFamily="34" charset="0"/>
+                <a:ea typeface="Aptos" pitchFamily="34" charset="-122"/>
+                <a:cs typeface="Aptos" pitchFamily="34" charset="-120"/>
               </a:rPr>
               <a:t>{Varför — skadan som uppstår vid utlämnande}</a:t>
             </a:r>
@@ -12944,9 +12944,9 @@
                 <a:solidFill>
                   <a:srgbClr val="4A4A4A"/>
                 </a:solidFill>
-                <a:latin typeface="-apple-system" pitchFamily="34" charset="0"/>
-                <a:ea typeface="-apple-system" pitchFamily="34" charset="-122"/>
-                <a:cs typeface="-apple-system" pitchFamily="34" charset="-120"/>
+                <a:latin typeface="Aptos" pitchFamily="34" charset="0"/>
+                <a:ea typeface="Aptos" pitchFamily="34" charset="-122"/>
+                <a:cs typeface="Aptos" pitchFamily="34" charset="-120"/>
               </a:rPr>
               <a:t>{Uppgift som omfattas}</a:t>
             </a:r>
@@ -12988,9 +12988,9 @@
                 <a:solidFill>
                   <a:srgbClr val="4A4A4A"/>
                 </a:solidFill>
-                <a:latin typeface="-apple-system" pitchFamily="34" charset="0"/>
-                <a:ea typeface="-apple-system" pitchFamily="34" charset="-122"/>
-                <a:cs typeface="-apple-system" pitchFamily="34" charset="-120"/>
+                <a:latin typeface="Aptos" pitchFamily="34" charset="0"/>
+                <a:ea typeface="Aptos" pitchFamily="34" charset="-122"/>
+                <a:cs typeface="Aptos" pitchFamily="34" charset="-120"/>
               </a:rPr>
               <a:t>{Motivering}</a:t>
             </a:r>
@@ -13103,9 +13103,9 @@
                 <a:solidFill>
                   <a:srgbClr val="4A4A4A"/>
                 </a:solidFill>
-                <a:latin typeface="-apple-system" pitchFamily="34" charset="0"/>
-                <a:ea typeface="-apple-system" pitchFamily="34" charset="-122"/>
-                <a:cs typeface="-apple-system" pitchFamily="34" charset="-120"/>
+                <a:latin typeface="Aptos" pitchFamily="34" charset="0"/>
+                <a:ea typeface="Aptos" pitchFamily="34" charset="-122"/>
+                <a:cs typeface="Aptos" pitchFamily="34" charset="-120"/>
               </a:rPr>
               <a:t>{Uppgift som omfattas}</a:t>
             </a:r>
@@ -13147,9 +13147,9 @@
                 <a:solidFill>
                   <a:srgbClr val="4A4A4A"/>
                 </a:solidFill>
-                <a:latin typeface="-apple-system" pitchFamily="34" charset="0"/>
-                <a:ea typeface="-apple-system" pitchFamily="34" charset="-122"/>
-                <a:cs typeface="-apple-system" pitchFamily="34" charset="-120"/>
+                <a:latin typeface="Aptos" pitchFamily="34" charset="0"/>
+                <a:ea typeface="Aptos" pitchFamily="34" charset="-122"/>
+                <a:cs typeface="Aptos" pitchFamily="34" charset="-120"/>
               </a:rPr>
               <a:t>{Motivering}</a:t>
             </a:r>
@@ -13262,9 +13262,9 @@
                 <a:solidFill>
                   <a:srgbClr val="4A4A4A"/>
                 </a:solidFill>
-                <a:latin typeface="-apple-system" pitchFamily="34" charset="0"/>
-                <a:ea typeface="-apple-system" pitchFamily="34" charset="-122"/>
-                <a:cs typeface="-apple-system" pitchFamily="34" charset="-120"/>
+                <a:latin typeface="Aptos" pitchFamily="34" charset="0"/>
+                <a:ea typeface="Aptos" pitchFamily="34" charset="-122"/>
+                <a:cs typeface="Aptos" pitchFamily="34" charset="-120"/>
               </a:rPr>
               <a:t>{Uppgift som omfattas}</a:t>
             </a:r>
@@ -13306,9 +13306,9 @@
                 <a:solidFill>
                   <a:srgbClr val="4A4A4A"/>
                 </a:solidFill>
-                <a:latin typeface="-apple-system" pitchFamily="34" charset="0"/>
-                <a:ea typeface="-apple-system" pitchFamily="34" charset="-122"/>
-                <a:cs typeface="-apple-system" pitchFamily="34" charset="-120"/>
+                <a:latin typeface="Aptos" pitchFamily="34" charset="0"/>
+                <a:ea typeface="Aptos" pitchFamily="34" charset="-122"/>
+                <a:cs typeface="Aptos" pitchFamily="34" charset="-120"/>
               </a:rPr>
               <a:t>{Motivering}</a:t>
             </a:r>
@@ -13511,9 +13511,9 @@
                 <a:solidFill>
                   <a:srgbClr val="4A4A4A"/>
                 </a:solidFill>
-                <a:latin typeface="-apple-system" pitchFamily="34" charset="0"/>
-                <a:ea typeface="-apple-system" pitchFamily="34" charset="-122"/>
-                <a:cs typeface="-apple-system" pitchFamily="34" charset="-120"/>
+                <a:latin typeface="Aptos" pitchFamily="34" charset="0"/>
+                <a:ea typeface="Aptos" pitchFamily="34" charset="-122"/>
+                <a:cs typeface="Aptos" pitchFamily="34" charset="-120"/>
               </a:rPr>
               <a:t>17 · CERTIFIERINGAR</a:t>
             </a:r>
@@ -13555,9 +13555,9 @@
                 <a:solidFill>
                   <a:srgbClr val="1A1A1A"/>
                 </a:solidFill>
-                <a:latin typeface="-apple-system" pitchFamily="34" charset="0"/>
-                <a:ea typeface="-apple-system" pitchFamily="34" charset="-122"/>
-                <a:cs typeface="-apple-system" pitchFamily="34" charset="-120"/>
+                <a:latin typeface="Aptos" pitchFamily="34" charset="0"/>
+                <a:ea typeface="Aptos" pitchFamily="34" charset="-122"/>
+                <a:cs typeface="Aptos" pitchFamily="34" charset="-120"/>
               </a:rPr>
               <a:t>Certifieringar och kvalitetsmärkningar</a:t>
             </a:r>
@@ -13623,9 +13623,9 @@
                 <a:solidFill>
                   <a:srgbClr val="1A1A1A"/>
                 </a:solidFill>
-                <a:latin typeface="-apple-system" pitchFamily="34" charset="0"/>
-                <a:ea typeface="-apple-system" pitchFamily="34" charset="-122"/>
-                <a:cs typeface="-apple-system" pitchFamily="34" charset="-120"/>
+                <a:latin typeface="Aptos" pitchFamily="34" charset="0"/>
+                <a:ea typeface="Aptos" pitchFamily="34" charset="-122"/>
+                <a:cs typeface="Aptos" pitchFamily="34" charset="-120"/>
               </a:rPr>
               <a:t>ISO 9001</a:t>
             </a:r>
@@ -13667,9 +13667,9 @@
                 <a:solidFill>
                   <a:srgbClr val="4A4A4A"/>
                 </a:solidFill>
-                <a:latin typeface="-apple-system" pitchFamily="34" charset="0"/>
-                <a:ea typeface="-apple-system" pitchFamily="34" charset="-122"/>
-                <a:cs typeface="-apple-system" pitchFamily="34" charset="-120"/>
+                <a:latin typeface="Aptos" pitchFamily="34" charset="0"/>
+                <a:ea typeface="Aptos" pitchFamily="34" charset="-122"/>
+                <a:cs typeface="Aptos" pitchFamily="34" charset="-120"/>
               </a:rPr>
               <a:t>Kvalitetsledningssystem</a:t>
             </a:r>
@@ -13899,9 +13899,9 @@
                 <a:solidFill>
                   <a:srgbClr val="1A1A1A"/>
                 </a:solidFill>
-                <a:latin typeface="-apple-system" pitchFamily="34" charset="0"/>
-                <a:ea typeface="-apple-system" pitchFamily="34" charset="-122"/>
-                <a:cs typeface="-apple-system" pitchFamily="34" charset="-120"/>
+                <a:latin typeface="Aptos" pitchFamily="34" charset="0"/>
+                <a:ea typeface="Aptos" pitchFamily="34" charset="-122"/>
+                <a:cs typeface="Aptos" pitchFamily="34" charset="-120"/>
               </a:rPr>
               <a:t>ISO 27001</a:t>
             </a:r>
@@ -13943,9 +13943,9 @@
                 <a:solidFill>
                   <a:srgbClr val="4A4A4A"/>
                 </a:solidFill>
-                <a:latin typeface="-apple-system" pitchFamily="34" charset="0"/>
-                <a:ea typeface="-apple-system" pitchFamily="34" charset="-122"/>
-                <a:cs typeface="-apple-system" pitchFamily="34" charset="-120"/>
+                <a:latin typeface="Aptos" pitchFamily="34" charset="0"/>
+                <a:ea typeface="Aptos" pitchFamily="34" charset="-122"/>
+                <a:cs typeface="Aptos" pitchFamily="34" charset="-120"/>
               </a:rPr>
               <a:t>Ledningssystem för informationssäkerhet</a:t>
             </a:r>
@@ -14175,9 +14175,9 @@
                 <a:solidFill>
                   <a:srgbClr val="1A1A1A"/>
                 </a:solidFill>
-                <a:latin typeface="-apple-system" pitchFamily="34" charset="0"/>
-                <a:ea typeface="-apple-system" pitchFamily="34" charset="-122"/>
-                <a:cs typeface="-apple-system" pitchFamily="34" charset="-120"/>
+                <a:latin typeface="Aptos" pitchFamily="34" charset="0"/>
+                <a:ea typeface="Aptos" pitchFamily="34" charset="-122"/>
+                <a:cs typeface="Aptos" pitchFamily="34" charset="-120"/>
               </a:rPr>
               <a:t>ISO 14001</a:t>
             </a:r>
@@ -14219,9 +14219,9 @@
                 <a:solidFill>
                   <a:srgbClr val="4A4A4A"/>
                 </a:solidFill>
-                <a:latin typeface="-apple-system" pitchFamily="34" charset="0"/>
-                <a:ea typeface="-apple-system" pitchFamily="34" charset="-122"/>
-                <a:cs typeface="-apple-system" pitchFamily="34" charset="-120"/>
+                <a:latin typeface="Aptos" pitchFamily="34" charset="0"/>
+                <a:ea typeface="Aptos" pitchFamily="34" charset="-122"/>
+                <a:cs typeface="Aptos" pitchFamily="34" charset="-120"/>
               </a:rPr>
               <a:t>Miljöledningssystem</a:t>
             </a:r>
@@ -14451,9 +14451,9 @@
                 <a:solidFill>
                   <a:srgbClr val="1A1A1A"/>
                 </a:solidFill>
-                <a:latin typeface="-apple-system" pitchFamily="34" charset="0"/>
-                <a:ea typeface="-apple-system" pitchFamily="34" charset="-122"/>
-                <a:cs typeface="-apple-system" pitchFamily="34" charset="-120"/>
+                <a:latin typeface="Aptos" pitchFamily="34" charset="0"/>
+                <a:ea typeface="Aptos" pitchFamily="34" charset="-122"/>
+                <a:cs typeface="Aptos" pitchFamily="34" charset="-120"/>
               </a:rPr>
               <a:t>{Övrig relevant certifiering}</a:t>
             </a:r>
@@ -14495,9 +14495,9 @@
                 <a:solidFill>
                   <a:srgbClr val="4A4A4A"/>
                 </a:solidFill>
-                <a:latin typeface="-apple-system" pitchFamily="34" charset="0"/>
-                <a:ea typeface="-apple-system" pitchFamily="34" charset="-122"/>
-                <a:cs typeface="-apple-system" pitchFamily="34" charset="-120"/>
+                <a:latin typeface="Aptos" pitchFamily="34" charset="0"/>
+                <a:ea typeface="Aptos" pitchFamily="34" charset="-122"/>
+                <a:cs typeface="Aptos" pitchFamily="34" charset="-120"/>
               </a:rPr>
               <a:t>{Beskrivning}</a:t>
             </a:r>
@@ -14905,9 +14905,9 @@
                 <a:solidFill>
                   <a:srgbClr val="4A4A4A"/>
                 </a:solidFill>
-                <a:latin typeface="-apple-system" pitchFamily="34" charset="0"/>
-                <a:ea typeface="-apple-system" pitchFamily="34" charset="-122"/>
-                <a:cs typeface="-apple-system" pitchFamily="34" charset="-120"/>
+                <a:latin typeface="Aptos" pitchFamily="34" charset="0"/>
+                <a:ea typeface="Aptos" pitchFamily="34" charset="-122"/>
+                <a:cs typeface="Aptos" pitchFamily="34" charset="-120"/>
               </a:rPr>
               <a:t>02 · INNEHÅLL</a:t>
             </a:r>
@@ -14949,9 +14949,9 @@
                 <a:solidFill>
                   <a:srgbClr val="1A1A1A"/>
                 </a:solidFill>
-                <a:latin typeface="-apple-system" pitchFamily="34" charset="0"/>
-                <a:ea typeface="-apple-system" pitchFamily="34" charset="-122"/>
-                <a:cs typeface="-apple-system" pitchFamily="34" charset="-120"/>
+                <a:latin typeface="Aptos" pitchFamily="34" charset="0"/>
+                <a:ea typeface="Aptos" pitchFamily="34" charset="-122"/>
+                <a:cs typeface="Aptos" pitchFamily="34" charset="-120"/>
               </a:rPr>
               <a:t>Innehållsförteckning</a:t>
             </a:r>
@@ -15058,9 +15058,9 @@
                 <a:solidFill>
                   <a:srgbClr val="1A1A1A"/>
                 </a:solidFill>
-                <a:latin typeface="-apple-system" pitchFamily="34" charset="0"/>
-                <a:ea typeface="-apple-system" pitchFamily="34" charset="-122"/>
-                <a:cs typeface="-apple-system" pitchFamily="34" charset="-120"/>
+                <a:latin typeface="Aptos" pitchFamily="34" charset="0"/>
+                <a:ea typeface="Aptos" pitchFamily="34" charset="-122"/>
+                <a:cs typeface="Aptos" pitchFamily="34" charset="-120"/>
               </a:rPr>
               <a:t>Försättssida</a:t>
             </a:r>
@@ -15167,9 +15167,9 @@
                 <a:solidFill>
                   <a:srgbClr val="1A1A1A"/>
                 </a:solidFill>
-                <a:latin typeface="-apple-system" pitchFamily="34" charset="0"/>
-                <a:ea typeface="-apple-system" pitchFamily="34" charset="-122"/>
-                <a:cs typeface="-apple-system" pitchFamily="34" charset="-120"/>
+                <a:latin typeface="Aptos" pitchFamily="34" charset="0"/>
+                <a:ea typeface="Aptos" pitchFamily="34" charset="-122"/>
+                <a:cs typeface="Aptos" pitchFamily="34" charset="-120"/>
               </a:rPr>
               <a:t>Fas 4 — detalj</a:t>
             </a:r>
@@ -15276,9 +15276,9 @@
                 <a:solidFill>
                   <a:srgbClr val="1A1A1A"/>
                 </a:solidFill>
-                <a:latin typeface="-apple-system" pitchFamily="34" charset="0"/>
-                <a:ea typeface="-apple-system" pitchFamily="34" charset="-122"/>
-                <a:cs typeface="-apple-system" pitchFamily="34" charset="-120"/>
+                <a:latin typeface="Aptos" pitchFamily="34" charset="0"/>
+                <a:ea typeface="Aptos" pitchFamily="34" charset="-122"/>
+                <a:cs typeface="Aptos" pitchFamily="34" charset="-120"/>
               </a:rPr>
               <a:t>Innehåll</a:t>
             </a:r>
@@ -15385,9 +15385,9 @@
                 <a:solidFill>
                   <a:srgbClr val="1A1A1A"/>
                 </a:solidFill>
-                <a:latin typeface="-apple-system" pitchFamily="34" charset="0"/>
-                <a:ea typeface="-apple-system" pitchFamily="34" charset="-122"/>
-                <a:cs typeface="-apple-system" pitchFamily="34" charset="-120"/>
+                <a:latin typeface="Aptos" pitchFamily="34" charset="0"/>
+                <a:ea typeface="Aptos" pitchFamily="34" charset="-122"/>
+                <a:cs typeface="Aptos" pitchFamily="34" charset="-120"/>
               </a:rPr>
               <a:t>Kvalitetssäkring</a:t>
             </a:r>
@@ -15494,9 +15494,9 @@
                 <a:solidFill>
                   <a:srgbClr val="1A1A1A"/>
                 </a:solidFill>
-                <a:latin typeface="-apple-system" pitchFamily="34" charset="0"/>
-                <a:ea typeface="-apple-system" pitchFamily="34" charset="-122"/>
-                <a:cs typeface="-apple-system" pitchFamily="34" charset="-120"/>
+                <a:latin typeface="Aptos" pitchFamily="34" charset="0"/>
+                <a:ea typeface="Aptos" pitchFamily="34" charset="-122"/>
+                <a:cs typeface="Aptos" pitchFamily="34" charset="-120"/>
               </a:rPr>
               <a:t>Vår förståelse — Kunden idag</a:t>
             </a:r>
@@ -15603,9 +15603,9 @@
                 <a:solidFill>
                   <a:srgbClr val="1A1A1A"/>
                 </a:solidFill>
-                <a:latin typeface="-apple-system" pitchFamily="34" charset="0"/>
-                <a:ea typeface="-apple-system" pitchFamily="34" charset="-122"/>
-                <a:cs typeface="-apple-system" pitchFamily="34" charset="-120"/>
+                <a:latin typeface="Aptos" pitchFamily="34" charset="0"/>
+                <a:ea typeface="Aptos" pitchFamily="34" charset="-122"/>
+                <a:cs typeface="Aptos" pitchFamily="34" charset="-120"/>
               </a:rPr>
               <a:t>Team, omfattning och pris</a:t>
             </a:r>
@@ -15712,9 +15712,9 @@
                 <a:solidFill>
                   <a:srgbClr val="1A1A1A"/>
                 </a:solidFill>
-                <a:latin typeface="-apple-system" pitchFamily="34" charset="0"/>
-                <a:ea typeface="-apple-system" pitchFamily="34" charset="-122"/>
-                <a:cs typeface="-apple-system" pitchFamily="34" charset="-120"/>
+                <a:latin typeface="Aptos" pitchFamily="34" charset="0"/>
+                <a:ea typeface="Aptos" pitchFamily="34" charset="-122"/>
+                <a:cs typeface="Aptos" pitchFamily="34" charset="-120"/>
               </a:rPr>
               <a:t>Vår förståelse — Uppdraget</a:t>
             </a:r>
@@ -15821,9 +15821,9 @@
                 <a:solidFill>
                   <a:srgbClr val="1A1A1A"/>
                 </a:solidFill>
-                <a:latin typeface="-apple-system" pitchFamily="34" charset="0"/>
-                <a:ea typeface="-apple-system" pitchFamily="34" charset="-122"/>
-                <a:cs typeface="-apple-system" pitchFamily="34" charset="-120"/>
+                <a:latin typeface="Aptos" pitchFamily="34" charset="0"/>
+                <a:ea typeface="Aptos" pitchFamily="34" charset="-122"/>
+                <a:cs typeface="Aptos" pitchFamily="34" charset="-120"/>
               </a:rPr>
               <a:t>Uppfyllelse av ska-krav</a:t>
             </a:r>
@@ -15930,9 +15930,9 @@
                 <a:solidFill>
                   <a:srgbClr val="1A1A1A"/>
                 </a:solidFill>
-                <a:latin typeface="-apple-system" pitchFamily="34" charset="0"/>
-                <a:ea typeface="-apple-system" pitchFamily="34" charset="-122"/>
-                <a:cs typeface="-apple-system" pitchFamily="34" charset="-120"/>
+                <a:latin typeface="Aptos" pitchFamily="34" charset="0"/>
+                <a:ea typeface="Aptos" pitchFamily="34" charset="-122"/>
+                <a:cs typeface="Aptos" pitchFamily="34" charset="-120"/>
               </a:rPr>
               <a:t>Vår förståelse — Utmaningar och värde</a:t>
             </a:r>
@@ -16039,9 +16039,9 @@
                 <a:solidFill>
                   <a:srgbClr val="1A1A1A"/>
                 </a:solidFill>
-                <a:latin typeface="-apple-system" pitchFamily="34" charset="0"/>
-                <a:ea typeface="-apple-system" pitchFamily="34" charset="-122"/>
-                <a:cs typeface="-apple-system" pitchFamily="34" charset="-120"/>
+                <a:latin typeface="Aptos" pitchFamily="34" charset="0"/>
+                <a:ea typeface="Aptos" pitchFamily="34" charset="-122"/>
+                <a:cs typeface="Aptos" pitchFamily="34" charset="-120"/>
               </a:rPr>
               <a:t>Referensuppdrag 1</a:t>
             </a:r>
@@ -16148,9 +16148,9 @@
                 <a:solidFill>
                   <a:srgbClr val="1A1A1A"/>
                 </a:solidFill>
-                <a:latin typeface="-apple-system" pitchFamily="34" charset="0"/>
-                <a:ea typeface="-apple-system" pitchFamily="34" charset="-122"/>
-                <a:cs typeface="-apple-system" pitchFamily="34" charset="-120"/>
+                <a:latin typeface="Aptos" pitchFamily="34" charset="0"/>
+                <a:ea typeface="Aptos" pitchFamily="34" charset="-122"/>
+                <a:cs typeface="Aptos" pitchFamily="34" charset="-120"/>
               </a:rPr>
               <a:t>Genomförande — översikt</a:t>
             </a:r>
@@ -16257,9 +16257,9 @@
                 <a:solidFill>
                   <a:srgbClr val="1A1A1A"/>
                 </a:solidFill>
-                <a:latin typeface="-apple-system" pitchFamily="34" charset="0"/>
-                <a:ea typeface="-apple-system" pitchFamily="34" charset="-122"/>
-                <a:cs typeface="-apple-system" pitchFamily="34" charset="-120"/>
+                <a:latin typeface="Aptos" pitchFamily="34" charset="0"/>
+                <a:ea typeface="Aptos" pitchFamily="34" charset="-122"/>
+                <a:cs typeface="Aptos" pitchFamily="34" charset="-120"/>
               </a:rPr>
               <a:t>Referensuppdrag 2</a:t>
             </a:r>
@@ -16366,9 +16366,9 @@
                 <a:solidFill>
                   <a:srgbClr val="1A1A1A"/>
                 </a:solidFill>
-                <a:latin typeface="-apple-system" pitchFamily="34" charset="0"/>
-                <a:ea typeface="-apple-system" pitchFamily="34" charset="-122"/>
-                <a:cs typeface="-apple-system" pitchFamily="34" charset="-120"/>
+                <a:latin typeface="Aptos" pitchFamily="34" charset="0"/>
+                <a:ea typeface="Aptos" pitchFamily="34" charset="-122"/>
+                <a:cs typeface="Aptos" pitchFamily="34" charset="-120"/>
               </a:rPr>
               <a:t>Fas 1 — detalj</a:t>
             </a:r>
@@ -16475,9 +16475,9 @@
                 <a:solidFill>
                   <a:srgbClr val="1A1A1A"/>
                 </a:solidFill>
-                <a:latin typeface="-apple-system" pitchFamily="34" charset="0"/>
-                <a:ea typeface="-apple-system" pitchFamily="34" charset="-122"/>
-                <a:cs typeface="-apple-system" pitchFamily="34" charset="-120"/>
+                <a:latin typeface="Aptos" pitchFamily="34" charset="0"/>
+                <a:ea typeface="Aptos" pitchFamily="34" charset="-122"/>
+                <a:cs typeface="Aptos" pitchFamily="34" charset="-120"/>
               </a:rPr>
               <a:t>Anbudssekretess</a:t>
             </a:r>
@@ -16584,9 +16584,9 @@
                 <a:solidFill>
                   <a:srgbClr val="1A1A1A"/>
                 </a:solidFill>
-                <a:latin typeface="-apple-system" pitchFamily="34" charset="0"/>
-                <a:ea typeface="-apple-system" pitchFamily="34" charset="-122"/>
-                <a:cs typeface="-apple-system" pitchFamily="34" charset="-120"/>
+                <a:latin typeface="Aptos" pitchFamily="34" charset="0"/>
+                <a:ea typeface="Aptos" pitchFamily="34" charset="-122"/>
+                <a:cs typeface="Aptos" pitchFamily="34" charset="-120"/>
               </a:rPr>
               <a:t>Fas 2 — detalj</a:t>
             </a:r>
@@ -16693,9 +16693,9 @@
                 <a:solidFill>
                   <a:srgbClr val="1A1A1A"/>
                 </a:solidFill>
-                <a:latin typeface="-apple-system" pitchFamily="34" charset="0"/>
-                <a:ea typeface="-apple-system" pitchFamily="34" charset="-122"/>
-                <a:cs typeface="-apple-system" pitchFamily="34" charset="-120"/>
+                <a:latin typeface="Aptos" pitchFamily="34" charset="0"/>
+                <a:ea typeface="Aptos" pitchFamily="34" charset="-122"/>
+                <a:cs typeface="Aptos" pitchFamily="34" charset="-120"/>
               </a:rPr>
               <a:t>Certifieringar</a:t>
             </a:r>
@@ -16775,9 +16775,9 @@
                 <a:solidFill>
                   <a:srgbClr val="1A1A1A"/>
                 </a:solidFill>
-                <a:latin typeface="-apple-system" pitchFamily="34" charset="0"/>
-                <a:ea typeface="-apple-system" pitchFamily="34" charset="-122"/>
-                <a:cs typeface="-apple-system" pitchFamily="34" charset="-120"/>
+                <a:latin typeface="Aptos" pitchFamily="34" charset="0"/>
+                <a:ea typeface="Aptos" pitchFamily="34" charset="-122"/>
+                <a:cs typeface="Aptos" pitchFamily="34" charset="-120"/>
               </a:rPr>
               <a:t>Fas 3 — detalj</a:t>
             </a:r>
@@ -16980,9 +16980,9 @@
                 <a:solidFill>
                   <a:srgbClr val="4A4A4A"/>
                 </a:solidFill>
-                <a:latin typeface="-apple-system" pitchFamily="34" charset="0"/>
-                <a:ea typeface="-apple-system" pitchFamily="34" charset="-122"/>
-                <a:cs typeface="-apple-system" pitchFamily="34" charset="-120"/>
+                <a:latin typeface="Aptos" pitchFamily="34" charset="0"/>
+                <a:ea typeface="Aptos" pitchFamily="34" charset="-122"/>
+                <a:cs typeface="Aptos" pitchFamily="34" charset="-120"/>
               </a:rPr>
               <a:t>03 · VÅR FÖRSTÅELSE AV UPPDRAGET</a:t>
             </a:r>
@@ -17024,9 +17024,9 @@
                 <a:solidFill>
                   <a:srgbClr val="1A1A1A"/>
                 </a:solidFill>
-                <a:latin typeface="-apple-system" pitchFamily="34" charset="0"/>
-                <a:ea typeface="-apple-system" pitchFamily="34" charset="-122"/>
-                <a:cs typeface="-apple-system" pitchFamily="34" charset="-120"/>
+                <a:latin typeface="Aptos" pitchFamily="34" charset="0"/>
+                <a:ea typeface="Aptos" pitchFamily="34" charset="-122"/>
+                <a:cs typeface="Aptos" pitchFamily="34" charset="-120"/>
               </a:rPr>
               <a:t>Kunden idag</a:t>
             </a:r>
@@ -17147,9 +17147,9 @@
                 <a:solidFill>
                   <a:srgbClr val="1A1A1A"/>
                 </a:solidFill>
-                <a:latin typeface="-apple-system" pitchFamily="34" charset="0"/>
-                <a:ea typeface="-apple-system" pitchFamily="34" charset="-122"/>
-                <a:cs typeface="-apple-system" pitchFamily="34" charset="-120"/>
+                <a:latin typeface="Aptos" pitchFamily="34" charset="0"/>
+                <a:ea typeface="Aptos" pitchFamily="34" charset="-122"/>
+                <a:cs typeface="Aptos" pitchFamily="34" charset="-120"/>
               </a:rPr>
               <a:t>{Nuläge}</a:t>
             </a:r>
@@ -17271,9 +17271,9 @@
                 <a:solidFill>
                   <a:srgbClr val="1A1A1A"/>
                 </a:solidFill>
-                <a:latin typeface="-apple-system" pitchFamily="34" charset="0"/>
-                <a:ea typeface="-apple-system" pitchFamily="34" charset="-122"/>
-                <a:cs typeface="-apple-system" pitchFamily="34" charset="-120"/>
+                <a:latin typeface="Aptos" pitchFamily="34" charset="0"/>
+                <a:ea typeface="Aptos" pitchFamily="34" charset="-122"/>
+                <a:cs typeface="Aptos" pitchFamily="34" charset="-120"/>
               </a:rPr>
               <a:t>{Smärtpunkter}</a:t>
             </a:r>
@@ -17476,9 +17476,9 @@
                 <a:solidFill>
                   <a:srgbClr val="4A4A4A"/>
                 </a:solidFill>
-                <a:latin typeface="-apple-system" pitchFamily="34" charset="0"/>
-                <a:ea typeface="-apple-system" pitchFamily="34" charset="-122"/>
-                <a:cs typeface="-apple-system" pitchFamily="34" charset="-120"/>
+                <a:latin typeface="Aptos" pitchFamily="34" charset="0"/>
+                <a:ea typeface="Aptos" pitchFamily="34" charset="-122"/>
+                <a:cs typeface="Aptos" pitchFamily="34" charset="-120"/>
               </a:rPr>
               <a:t>04 · VÅR FÖRSTÅELSE AV UPPDRAGET</a:t>
             </a:r>
@@ -17520,9 +17520,9 @@
                 <a:solidFill>
                   <a:srgbClr val="1A1A1A"/>
                 </a:solidFill>
-                <a:latin typeface="-apple-system" pitchFamily="34" charset="0"/>
-                <a:ea typeface="-apple-system" pitchFamily="34" charset="-122"/>
-                <a:cs typeface="-apple-system" pitchFamily="34" charset="-120"/>
+                <a:latin typeface="Aptos" pitchFamily="34" charset="0"/>
+                <a:ea typeface="Aptos" pitchFamily="34" charset="-122"/>
+                <a:cs typeface="Aptos" pitchFamily="34" charset="-120"/>
               </a:rPr>
               <a:t>Uppdragsbeskrivning</a:t>
             </a:r>
@@ -17564,9 +17564,9 @@
                 <a:solidFill>
                   <a:srgbClr val="4A4A4A"/>
                 </a:solidFill>
-                <a:latin typeface="-apple-system" pitchFamily="34" charset="0"/>
-                <a:ea typeface="-apple-system" pitchFamily="34" charset="-122"/>
-                <a:cs typeface="-apple-system" pitchFamily="34" charset="-120"/>
+                <a:latin typeface="Aptos" pitchFamily="34" charset="0"/>
+                <a:ea typeface="Aptos" pitchFamily="34" charset="-122"/>
+                <a:cs typeface="Aptos" pitchFamily="34" charset="-120"/>
               </a:rPr>
               <a:t>Uppdraget parafraserat — så läser vi RFP:n</a:t>
             </a:r>
@@ -17878,9 +17878,9 @@
                 <a:solidFill>
                   <a:srgbClr val="4A4A4A"/>
                 </a:solidFill>
-                <a:latin typeface="-apple-system" pitchFamily="34" charset="0"/>
-                <a:ea typeface="-apple-system" pitchFamily="34" charset="-122"/>
-                <a:cs typeface="-apple-system" pitchFamily="34" charset="-120"/>
+                <a:latin typeface="Aptos" pitchFamily="34" charset="0"/>
+                <a:ea typeface="Aptos" pitchFamily="34" charset="-122"/>
+                <a:cs typeface="Aptos" pitchFamily="34" charset="-120"/>
               </a:rPr>
               <a:t>05 · VÅR FÖRSTÅELSE AV UPPDRAGET</a:t>
             </a:r>
@@ -17922,9 +17922,9 @@
                 <a:solidFill>
                   <a:srgbClr val="1A1A1A"/>
                 </a:solidFill>
-                <a:latin typeface="-apple-system" pitchFamily="34" charset="0"/>
-                <a:ea typeface="-apple-system" pitchFamily="34" charset="-122"/>
-                <a:cs typeface="-apple-system" pitchFamily="34" charset="-120"/>
+                <a:latin typeface="Aptos" pitchFamily="34" charset="0"/>
+                <a:ea typeface="Aptos" pitchFamily="34" charset="-122"/>
+                <a:cs typeface="Aptos" pitchFamily="34" charset="-120"/>
               </a:rPr>
               <a:t>Vad vi ser</a:t>
             </a:r>
@@ -18071,9 +18071,9 @@
                 <a:solidFill>
                   <a:srgbClr val="4A4A4A"/>
                 </a:solidFill>
-                <a:latin typeface="-apple-system" pitchFamily="34" charset="0"/>
-                <a:ea typeface="-apple-system" pitchFamily="34" charset="-122"/>
-                <a:cs typeface="-apple-system" pitchFamily="34" charset="-120"/>
+                <a:latin typeface="Aptos" pitchFamily="34" charset="0"/>
+                <a:ea typeface="Aptos" pitchFamily="34" charset="-122"/>
+                <a:cs typeface="Aptos" pitchFamily="34" charset="-120"/>
               </a:rPr>
               <a:t>{</a:t>
             </a:r>
@@ -18082,9 +18082,9 @@
                 <a:solidFill>
                   <a:srgbClr val="4A4A4A"/>
                 </a:solidFill>
-                <a:latin typeface="-apple-system" pitchFamily="34" charset="0"/>
-                <a:ea typeface="-apple-system" pitchFamily="34" charset="-122"/>
-                <a:cs typeface="-apple-system" pitchFamily="34" charset="-120"/>
+                <a:latin typeface="Aptos" pitchFamily="34" charset="0"/>
+                <a:ea typeface="Aptos" pitchFamily="34" charset="-122"/>
+                <a:cs typeface="Aptos" pitchFamily="34" charset="-120"/>
               </a:rPr>
               <a:t>Utmaningar</a:t>
             </a:r>
@@ -18093,9 +18093,9 @@
                 <a:solidFill>
                   <a:srgbClr val="4A4A4A"/>
                 </a:solidFill>
-                <a:latin typeface="-apple-system" pitchFamily="34" charset="0"/>
-                <a:ea typeface="-apple-system" pitchFamily="34" charset="-122"/>
-                <a:cs typeface="-apple-system" pitchFamily="34" charset="-120"/>
+                <a:latin typeface="Aptos" pitchFamily="34" charset="0"/>
+                <a:ea typeface="Aptos" pitchFamily="34" charset="-122"/>
+                <a:cs typeface="Aptos" pitchFamily="34" charset="-120"/>
               </a:rPr>
               <a:t>}</a:t>
             </a:r>
@@ -18215,9 +18215,9 @@
                 <a:solidFill>
                   <a:srgbClr val="4A4A4A"/>
                 </a:solidFill>
-                <a:latin typeface="-apple-system" pitchFamily="34" charset="0"/>
-                <a:ea typeface="-apple-system" pitchFamily="34" charset="-122"/>
-                <a:cs typeface="-apple-system" pitchFamily="34" charset="-120"/>
+                <a:latin typeface="Aptos" pitchFamily="34" charset="0"/>
+                <a:ea typeface="Aptos" pitchFamily="34" charset="-122"/>
+                <a:cs typeface="Aptos" pitchFamily="34" charset="-120"/>
               </a:rPr>
               <a:t>{</a:t>
             </a:r>
@@ -18226,9 +18226,9 @@
                 <a:solidFill>
                   <a:srgbClr val="4A4A4A"/>
                 </a:solidFill>
-                <a:latin typeface="-apple-system" pitchFamily="34" charset="0"/>
-                <a:ea typeface="-apple-system" pitchFamily="34" charset="-122"/>
-                <a:cs typeface="-apple-system" pitchFamily="34" charset="-120"/>
+                <a:latin typeface="Aptos" pitchFamily="34" charset="0"/>
+                <a:ea typeface="Aptos" pitchFamily="34" charset="-122"/>
+                <a:cs typeface="Aptos" pitchFamily="34" charset="-120"/>
               </a:rPr>
               <a:t>Värden</a:t>
             </a:r>
@@ -18237,9 +18237,9 @@
                 <a:solidFill>
                   <a:srgbClr val="4A4A4A"/>
                 </a:solidFill>
-                <a:latin typeface="-apple-system" pitchFamily="34" charset="0"/>
-                <a:ea typeface="-apple-system" pitchFamily="34" charset="-122"/>
-                <a:cs typeface="-apple-system" pitchFamily="34" charset="-120"/>
+                <a:latin typeface="Aptos" pitchFamily="34" charset="0"/>
+                <a:ea typeface="Aptos" pitchFamily="34" charset="-122"/>
+                <a:cs typeface="Aptos" pitchFamily="34" charset="-120"/>
               </a:rPr>
               <a:t>}</a:t>
             </a:r>
@@ -18508,9 +18508,9 @@
                 <a:solidFill>
                   <a:srgbClr val="4A4A4A"/>
                 </a:solidFill>
-                <a:latin typeface="-apple-system" pitchFamily="34" charset="0"/>
-                <a:ea typeface="-apple-system" pitchFamily="34" charset="-122"/>
-                <a:cs typeface="-apple-system" pitchFamily="34" charset="-120"/>
+                <a:latin typeface="Aptos" pitchFamily="34" charset="0"/>
+                <a:ea typeface="Aptos" pitchFamily="34" charset="-122"/>
+                <a:cs typeface="Aptos" pitchFamily="34" charset="-120"/>
               </a:rPr>
               <a:t>06 · GENOMFÖRANDE</a:t>
             </a:r>
@@ -18552,9 +18552,9 @@
                 <a:solidFill>
                   <a:srgbClr val="1A1A1A"/>
                 </a:solidFill>
-                <a:latin typeface="-apple-system" pitchFamily="34" charset="0"/>
-                <a:ea typeface="-apple-system" pitchFamily="34" charset="-122"/>
-                <a:cs typeface="-apple-system" pitchFamily="34" charset="-120"/>
+                <a:latin typeface="Aptos" pitchFamily="34" charset="0"/>
+                <a:ea typeface="Aptos" pitchFamily="34" charset="-122"/>
+                <a:cs typeface="Aptos" pitchFamily="34" charset="-120"/>
               </a:rPr>
               <a:t>Genomförande — översikt</a:t>
             </a:r>
@@ -18661,9 +18661,9 @@
                 <a:solidFill>
                   <a:srgbClr val="1A1A1A"/>
                 </a:solidFill>
-                <a:latin typeface="-apple-system" pitchFamily="34" charset="0"/>
-                <a:ea typeface="-apple-system" pitchFamily="34" charset="-122"/>
-                <a:cs typeface="-apple-system" pitchFamily="34" charset="-120"/>
+                <a:latin typeface="Aptos" pitchFamily="34" charset="0"/>
+                <a:ea typeface="Aptos" pitchFamily="34" charset="-122"/>
+                <a:cs typeface="Aptos" pitchFamily="34" charset="-120"/>
               </a:rPr>
               <a:t>{Fas 1 — namn}</a:t>
             </a:r>
@@ -18705,9 +18705,9 @@
                 <a:solidFill>
                   <a:srgbClr val="4A4A4A"/>
                 </a:solidFill>
-                <a:latin typeface="-apple-system" pitchFamily="34" charset="0"/>
-                <a:ea typeface="-apple-system" pitchFamily="34" charset="-122"/>
-                <a:cs typeface="-apple-system" pitchFamily="34" charset="-120"/>
+                <a:latin typeface="Aptos" pitchFamily="34" charset="0"/>
+                <a:ea typeface="Aptos" pitchFamily="34" charset="-122"/>
+                <a:cs typeface="Aptos" pitchFamily="34" charset="-120"/>
               </a:rPr>
               <a:t>{Fas 1 — kort beskrivning. Detaljer på nästa slide.}</a:t>
             </a:r>
@@ -18814,9 +18814,9 @@
                 <a:solidFill>
                   <a:srgbClr val="1A1A1A"/>
                 </a:solidFill>
-                <a:latin typeface="-apple-system" pitchFamily="34" charset="0"/>
-                <a:ea typeface="-apple-system" pitchFamily="34" charset="-122"/>
-                <a:cs typeface="-apple-system" pitchFamily="34" charset="-120"/>
+                <a:latin typeface="Aptos" pitchFamily="34" charset="0"/>
+                <a:ea typeface="Aptos" pitchFamily="34" charset="-122"/>
+                <a:cs typeface="Aptos" pitchFamily="34" charset="-120"/>
               </a:rPr>
               <a:t>{Fas 2 — namn}</a:t>
             </a:r>
@@ -18858,9 +18858,9 @@
                 <a:solidFill>
                   <a:srgbClr val="4A4A4A"/>
                 </a:solidFill>
-                <a:latin typeface="-apple-system" pitchFamily="34" charset="0"/>
-                <a:ea typeface="-apple-system" pitchFamily="34" charset="-122"/>
-                <a:cs typeface="-apple-system" pitchFamily="34" charset="-120"/>
+                <a:latin typeface="Aptos" pitchFamily="34" charset="0"/>
+                <a:ea typeface="Aptos" pitchFamily="34" charset="-122"/>
+                <a:cs typeface="Aptos" pitchFamily="34" charset="-120"/>
               </a:rPr>
               <a:t>{Fas 2 — beskrivning}</a:t>
             </a:r>
@@ -18967,9 +18967,9 @@
                 <a:solidFill>
                   <a:srgbClr val="1A1A1A"/>
                 </a:solidFill>
-                <a:latin typeface="-apple-system" pitchFamily="34" charset="0"/>
-                <a:ea typeface="-apple-system" pitchFamily="34" charset="-122"/>
-                <a:cs typeface="-apple-system" pitchFamily="34" charset="-120"/>
+                <a:latin typeface="Aptos" pitchFamily="34" charset="0"/>
+                <a:ea typeface="Aptos" pitchFamily="34" charset="-122"/>
+                <a:cs typeface="Aptos" pitchFamily="34" charset="-120"/>
               </a:rPr>
               <a:t>{Fas 3 — namn}</a:t>
             </a:r>
@@ -19011,9 +19011,9 @@
                 <a:solidFill>
                   <a:srgbClr val="4A4A4A"/>
                 </a:solidFill>
-                <a:latin typeface="-apple-system" pitchFamily="34" charset="0"/>
-                <a:ea typeface="-apple-system" pitchFamily="34" charset="-122"/>
-                <a:cs typeface="-apple-system" pitchFamily="34" charset="-120"/>
+                <a:latin typeface="Aptos" pitchFamily="34" charset="0"/>
+                <a:ea typeface="Aptos" pitchFamily="34" charset="-122"/>
+                <a:cs typeface="Aptos" pitchFamily="34" charset="-120"/>
               </a:rPr>
               <a:t>{Fas 3 — beskrivning}</a:t>
             </a:r>
@@ -19120,9 +19120,9 @@
                 <a:solidFill>
                   <a:srgbClr val="1A1A1A"/>
                 </a:solidFill>
-                <a:latin typeface="-apple-system" pitchFamily="34" charset="0"/>
-                <a:ea typeface="-apple-system" pitchFamily="34" charset="-122"/>
-                <a:cs typeface="-apple-system" pitchFamily="34" charset="-120"/>
+                <a:latin typeface="Aptos" pitchFamily="34" charset="0"/>
+                <a:ea typeface="Aptos" pitchFamily="34" charset="-122"/>
+                <a:cs typeface="Aptos" pitchFamily="34" charset="-120"/>
               </a:rPr>
               <a:t>{Fas 4 — namn}</a:t>
             </a:r>
@@ -19164,9 +19164,9 @@
                 <a:solidFill>
                   <a:srgbClr val="4A4A4A"/>
                 </a:solidFill>
-                <a:latin typeface="-apple-system" pitchFamily="34" charset="0"/>
-                <a:ea typeface="-apple-system" pitchFamily="34" charset="-122"/>
-                <a:cs typeface="-apple-system" pitchFamily="34" charset="-120"/>
+                <a:latin typeface="Aptos" pitchFamily="34" charset="0"/>
+                <a:ea typeface="Aptos" pitchFamily="34" charset="-122"/>
+                <a:cs typeface="Aptos" pitchFamily="34" charset="-120"/>
               </a:rPr>
               <a:t>{Fas 4 — beskrivning}</a:t>
             </a:r>
@@ -20173,9 +20173,9 @@
                 <a:solidFill>
                   <a:srgbClr val="1A1A1A"/>
                 </a:solidFill>
-                <a:latin typeface="-apple-system" pitchFamily="34" charset="0"/>
-                <a:ea typeface="-apple-system" pitchFamily="34" charset="-122"/>
-                <a:cs typeface="-apple-system" pitchFamily="34" charset="-120"/>
+                <a:latin typeface="Aptos" pitchFamily="34" charset="0"/>
+                <a:ea typeface="Aptos" pitchFamily="34" charset="-122"/>
+                <a:cs typeface="Aptos" pitchFamily="34" charset="-120"/>
               </a:rPr>
               <a:t>{Fas 1 — namn}</a:t>
             </a:r>
@@ -20217,9 +20217,9 @@
                 <a:solidFill>
                   <a:srgbClr val="4A4A4A"/>
                 </a:solidFill>
-                <a:latin typeface="-apple-system" pitchFamily="34" charset="0"/>
-                <a:ea typeface="-apple-system" pitchFamily="34" charset="-122"/>
-                <a:cs typeface="-apple-system" pitchFamily="34" charset="-120"/>
+                <a:latin typeface="Aptos" pitchFamily="34" charset="0"/>
+                <a:ea typeface="Aptos" pitchFamily="34" charset="-122"/>
+                <a:cs typeface="Aptos" pitchFamily="34" charset="-120"/>
               </a:rPr>
               <a:t>{M1–M2}</a:t>
             </a:r>
@@ -20385,9 +20385,9 @@
                 <a:solidFill>
                   <a:srgbClr val="1A1A1A"/>
                 </a:solidFill>
-                <a:latin typeface="-apple-system" pitchFamily="34" charset="0"/>
-                <a:ea typeface="-apple-system" pitchFamily="34" charset="-122"/>
-                <a:cs typeface="-apple-system" pitchFamily="34" charset="-120"/>
+                <a:latin typeface="Aptos" pitchFamily="34" charset="0"/>
+                <a:ea typeface="Aptos" pitchFamily="34" charset="-122"/>
+                <a:cs typeface="Aptos" pitchFamily="34" charset="-120"/>
               </a:rPr>
               <a:t>{Fas 2 — namn}</a:t>
             </a:r>
@@ -20429,9 +20429,9 @@
                 <a:solidFill>
                   <a:srgbClr val="4A4A4A"/>
                 </a:solidFill>
-                <a:latin typeface="-apple-system" pitchFamily="34" charset="0"/>
-                <a:ea typeface="-apple-system" pitchFamily="34" charset="-122"/>
-                <a:cs typeface="-apple-system" pitchFamily="34" charset="-120"/>
+                <a:latin typeface="Aptos" pitchFamily="34" charset="0"/>
+                <a:ea typeface="Aptos" pitchFamily="34" charset="-122"/>
+                <a:cs typeface="Aptos" pitchFamily="34" charset="-120"/>
               </a:rPr>
               <a:t>{M2–M5}</a:t>
             </a:r>
@@ -20597,9 +20597,9 @@
                 <a:solidFill>
                   <a:srgbClr val="1A1A1A"/>
                 </a:solidFill>
-                <a:latin typeface="-apple-system" pitchFamily="34" charset="0"/>
-                <a:ea typeface="-apple-system" pitchFamily="34" charset="-122"/>
-                <a:cs typeface="-apple-system" pitchFamily="34" charset="-120"/>
+                <a:latin typeface="Aptos" pitchFamily="34" charset="0"/>
+                <a:ea typeface="Aptos" pitchFamily="34" charset="-122"/>
+                <a:cs typeface="Aptos" pitchFamily="34" charset="-120"/>
               </a:rPr>
               <a:t>{Fas 3 — namn}</a:t>
             </a:r>
@@ -20641,9 +20641,9 @@
                 <a:solidFill>
                   <a:srgbClr val="4A4A4A"/>
                 </a:solidFill>
-                <a:latin typeface="-apple-system" pitchFamily="34" charset="0"/>
-                <a:ea typeface="-apple-system" pitchFamily="34" charset="-122"/>
-                <a:cs typeface="-apple-system" pitchFamily="34" charset="-120"/>
+                <a:latin typeface="Aptos" pitchFamily="34" charset="0"/>
+                <a:ea typeface="Aptos" pitchFamily="34" charset="-122"/>
+                <a:cs typeface="Aptos" pitchFamily="34" charset="-120"/>
               </a:rPr>
               <a:t>{M5–M9}</a:t>
             </a:r>
@@ -20809,9 +20809,9 @@
                 <a:solidFill>
                   <a:srgbClr val="1A1A1A"/>
                 </a:solidFill>
-                <a:latin typeface="-apple-system" pitchFamily="34" charset="0"/>
-                <a:ea typeface="-apple-system" pitchFamily="34" charset="-122"/>
-                <a:cs typeface="-apple-system" pitchFamily="34" charset="-120"/>
+                <a:latin typeface="Aptos" pitchFamily="34" charset="0"/>
+                <a:ea typeface="Aptos" pitchFamily="34" charset="-122"/>
+                <a:cs typeface="Aptos" pitchFamily="34" charset="-120"/>
               </a:rPr>
               <a:t>{Fas 4 — namn}</a:t>
             </a:r>
@@ -20853,9 +20853,9 @@
                 <a:solidFill>
                   <a:srgbClr val="4A4A4A"/>
                 </a:solidFill>
-                <a:latin typeface="-apple-system" pitchFamily="34" charset="0"/>
-                <a:ea typeface="-apple-system" pitchFamily="34" charset="-122"/>
-                <a:cs typeface="-apple-system" pitchFamily="34" charset="-120"/>
+                <a:latin typeface="Aptos" pitchFamily="34" charset="0"/>
+                <a:ea typeface="Aptos" pitchFamily="34" charset="-122"/>
+                <a:cs typeface="Aptos" pitchFamily="34" charset="-120"/>
               </a:rPr>
               <a:t>{M9–M12}</a:t>
             </a:r>
@@ -21155,9 +21155,9 @@
                 <a:solidFill>
                   <a:srgbClr val="4A4A4A"/>
                 </a:solidFill>
-                <a:latin typeface="-apple-system" pitchFamily="34" charset="0"/>
-                <a:ea typeface="-apple-system" pitchFamily="34" charset="-122"/>
-                <a:cs typeface="-apple-system" pitchFamily="34" charset="-120"/>
+                <a:latin typeface="Aptos" pitchFamily="34" charset="0"/>
+                <a:ea typeface="Aptos" pitchFamily="34" charset="-122"/>
+                <a:cs typeface="Aptos" pitchFamily="34" charset="-120"/>
               </a:rPr>
               <a:t>07 · GENOMFÖRANDE — FAS 1 AV 4</a:t>
             </a:r>
@@ -21226,9 +21226,9 @@
                 <a:solidFill>
                   <a:srgbClr val="2B5F5F"/>
                 </a:solidFill>
-                <a:latin typeface="-apple-system" pitchFamily="34" charset="0"/>
-                <a:ea typeface="-apple-system" pitchFamily="34" charset="-122"/>
-                <a:cs typeface="-apple-system" pitchFamily="34" charset="-120"/>
+                <a:latin typeface="Aptos" pitchFamily="34" charset="0"/>
+                <a:ea typeface="Aptos" pitchFamily="34" charset="-122"/>
+                <a:cs typeface="Aptos" pitchFamily="34" charset="-120"/>
               </a:rPr>
               <a:t>01</a:t>
             </a:r>
@@ -21311,9 +21311,9 @@
                 <a:solidFill>
                   <a:srgbClr val="1A1A1A"/>
                 </a:solidFill>
-                <a:latin typeface="-apple-system" pitchFamily="34" charset="0"/>
-                <a:ea typeface="-apple-system" pitchFamily="34" charset="-122"/>
-                <a:cs typeface="-apple-system" pitchFamily="34" charset="-120"/>
+                <a:latin typeface="Aptos" pitchFamily="34" charset="0"/>
+                <a:ea typeface="Aptos" pitchFamily="34" charset="-122"/>
+                <a:cs typeface="Aptos" pitchFamily="34" charset="-120"/>
               </a:rPr>
               <a:t>{Fas 1 — namn}</a:t>
             </a:r>
@@ -21477,9 +21477,9 @@
                 <a:solidFill>
                   <a:srgbClr val="1A1A1A"/>
                 </a:solidFill>
-                <a:latin typeface="-apple-system" pitchFamily="34" charset="0"/>
-                <a:ea typeface="-apple-system" pitchFamily="34" charset="-122"/>
-                <a:cs typeface="-apple-system" pitchFamily="34" charset="-120"/>
+                <a:latin typeface="Aptos" pitchFamily="34" charset="0"/>
+                <a:ea typeface="Aptos" pitchFamily="34" charset="-122"/>
+                <a:cs typeface="Aptos" pitchFamily="34" charset="-120"/>
               </a:rPr>
               <a:t>{Aktiviteter}</a:t>
             </a:r>
@@ -21602,9 +21602,9 @@
                 <a:solidFill>
                   <a:srgbClr val="1A1A1A"/>
                 </a:solidFill>
-                <a:latin typeface="-apple-system" pitchFamily="34" charset="0"/>
-                <a:ea typeface="-apple-system" pitchFamily="34" charset="-122"/>
-                <a:cs typeface="-apple-system" pitchFamily="34" charset="-120"/>
+                <a:latin typeface="Aptos" pitchFamily="34" charset="0"/>
+                <a:ea typeface="Aptos" pitchFamily="34" charset="-122"/>
+                <a:cs typeface="Aptos" pitchFamily="34" charset="-120"/>
               </a:rPr>
               <a:t>{Leveranser}</a:t>
             </a:r>
@@ -21752,9 +21752,9 @@
                 <a:solidFill>
                   <a:srgbClr val="1A1A1A"/>
                 </a:solidFill>
-                <a:latin typeface="-apple-system" pitchFamily="34" charset="0"/>
-                <a:ea typeface="-apple-system" pitchFamily="34" charset="-122"/>
-                <a:cs typeface="-apple-system" pitchFamily="34" charset="-120"/>
+                <a:latin typeface="Aptos" pitchFamily="34" charset="0"/>
+                <a:ea typeface="Aptos" pitchFamily="34" charset="-122"/>
+                <a:cs typeface="Aptos" pitchFamily="34" charset="-120"/>
               </a:rPr>
               <a:t>{Beslut}</a:t>
             </a:r>
@@ -22911,9 +22911,9 @@
                 <a:solidFill>
                   <a:srgbClr val="1A1A1A"/>
                 </a:solidFill>
-                <a:latin typeface="-apple-system" pitchFamily="34" charset="0"/>
-                <a:ea typeface="-apple-system" pitchFamily="34" charset="-122"/>
-                <a:cs typeface="-apple-system" pitchFamily="34" charset="-120"/>
+                <a:latin typeface="Aptos" pitchFamily="34" charset="0"/>
+                <a:ea typeface="Aptos" pitchFamily="34" charset="-122"/>
+                <a:cs typeface="Aptos" pitchFamily="34" charset="-120"/>
               </a:rPr>
               <a:t>{Risker}</a:t>
             </a:r>
@@ -23018,9 +23018,9 @@
                 <a:solidFill>
                   <a:srgbClr val="4A4A4A"/>
                 </a:solidFill>
-                <a:latin typeface="-apple-system" pitchFamily="34" charset="0"/>
-                <a:ea typeface="-apple-system" pitchFamily="34" charset="-122"/>
-                <a:cs typeface="-apple-system" pitchFamily="34" charset="-120"/>
+                <a:latin typeface="Aptos" pitchFamily="34" charset="0"/>
+                <a:ea typeface="Aptos" pitchFamily="34" charset="-122"/>
+                <a:cs typeface="Aptos" pitchFamily="34" charset="-120"/>
               </a:rPr>
               <a:t>08 · GENOMFÖRANDE — FAS 2 AV 4</a:t>
             </a:r>
@@ -23089,9 +23089,9 @@
                 <a:solidFill>
                   <a:srgbClr val="2B5F5F"/>
                 </a:solidFill>
-                <a:latin typeface="-apple-system" pitchFamily="34" charset="0"/>
-                <a:ea typeface="-apple-system" pitchFamily="34" charset="-122"/>
-                <a:cs typeface="-apple-system" pitchFamily="34" charset="-120"/>
+                <a:latin typeface="Aptos" pitchFamily="34" charset="0"/>
+                <a:ea typeface="Aptos" pitchFamily="34" charset="-122"/>
+                <a:cs typeface="Aptos" pitchFamily="34" charset="-120"/>
               </a:rPr>
               <a:t>02</a:t>
             </a:r>
@@ -23174,9 +23174,9 @@
                 <a:solidFill>
                   <a:srgbClr val="1A1A1A"/>
                 </a:solidFill>
-                <a:latin typeface="-apple-system" pitchFamily="34" charset="0"/>
-                <a:ea typeface="-apple-system" pitchFamily="34" charset="-122"/>
-                <a:cs typeface="-apple-system" pitchFamily="34" charset="-120"/>
+                <a:latin typeface="Aptos" pitchFamily="34" charset="0"/>
+                <a:ea typeface="Aptos" pitchFamily="34" charset="-122"/>
+                <a:cs typeface="Aptos" pitchFamily="34" charset="-120"/>
               </a:rPr>
               <a:t>{Fas 2 — namn}</a:t>
             </a:r>
@@ -23338,9 +23338,9 @@
                 <a:solidFill>
                   <a:srgbClr val="1A1A1A"/>
                 </a:solidFill>
-                <a:latin typeface="-apple-system" pitchFamily="34" charset="0"/>
-                <a:ea typeface="-apple-system" pitchFamily="34" charset="-122"/>
-                <a:cs typeface="-apple-system" pitchFamily="34" charset="-120"/>
+                <a:latin typeface="Aptos" pitchFamily="34" charset="0"/>
+                <a:ea typeface="Aptos" pitchFamily="34" charset="-122"/>
+                <a:cs typeface="Aptos" pitchFamily="34" charset="-120"/>
               </a:rPr>
               <a:t>{Aktivitet 1}</a:t>
             </a:r>
@@ -23382,9 +23382,9 @@
                 <a:solidFill>
                   <a:srgbClr val="1A1A1A"/>
                 </a:solidFill>
-                <a:latin typeface="-apple-system" pitchFamily="34" charset="0"/>
-                <a:ea typeface="-apple-system" pitchFamily="34" charset="-122"/>
-                <a:cs typeface="-apple-system" pitchFamily="34" charset="-120"/>
+                <a:latin typeface="Aptos" pitchFamily="34" charset="0"/>
+                <a:ea typeface="Aptos" pitchFamily="34" charset="-122"/>
+                <a:cs typeface="Aptos" pitchFamily="34" charset="-120"/>
               </a:rPr>
               <a:t>{Aktivitet 2}</a:t>
             </a:r>
@@ -23426,9 +23426,9 @@
                 <a:solidFill>
                   <a:srgbClr val="1A1A1A"/>
                 </a:solidFill>
-                <a:latin typeface="-apple-system" pitchFamily="34" charset="0"/>
-                <a:ea typeface="-apple-system" pitchFamily="34" charset="-122"/>
-                <a:cs typeface="-apple-system" pitchFamily="34" charset="-120"/>
+                <a:latin typeface="Aptos" pitchFamily="34" charset="0"/>
+                <a:ea typeface="Aptos" pitchFamily="34" charset="-122"/>
+                <a:cs typeface="Aptos" pitchFamily="34" charset="-120"/>
               </a:rPr>
               <a:t>{Aktivitet 3}</a:t>
             </a:r>
@@ -23470,9 +23470,9 @@
                 <a:solidFill>
                   <a:srgbClr val="1A1A1A"/>
                 </a:solidFill>
-                <a:latin typeface="-apple-system" pitchFamily="34" charset="0"/>
-                <a:ea typeface="-apple-system" pitchFamily="34" charset="-122"/>
-                <a:cs typeface="-apple-system" pitchFamily="34" charset="-120"/>
+                <a:latin typeface="Aptos" pitchFamily="34" charset="0"/>
+                <a:ea typeface="Aptos" pitchFamily="34" charset="-122"/>
+                <a:cs typeface="Aptos" pitchFamily="34" charset="-120"/>
               </a:rPr>
               <a:t>{Aktivitet 4}</a:t>
             </a:r>
@@ -23593,9 +23593,9 @@
                 <a:solidFill>
                   <a:srgbClr val="1A1A1A"/>
                 </a:solidFill>
-                <a:latin typeface="-apple-system" pitchFamily="34" charset="0"/>
-                <a:ea typeface="-apple-system" pitchFamily="34" charset="-122"/>
-                <a:cs typeface="-apple-system" pitchFamily="34" charset="-120"/>
+                <a:latin typeface="Aptos" pitchFamily="34" charset="0"/>
+                <a:ea typeface="Aptos" pitchFamily="34" charset="-122"/>
+                <a:cs typeface="Aptos" pitchFamily="34" charset="-120"/>
               </a:rPr>
               <a:t>{Leverans 1}</a:t>
             </a:r>
@@ -23637,9 +23637,9 @@
                 <a:solidFill>
                   <a:srgbClr val="1A1A1A"/>
                 </a:solidFill>
-                <a:latin typeface="-apple-system" pitchFamily="34" charset="0"/>
-                <a:ea typeface="-apple-system" pitchFamily="34" charset="-122"/>
-                <a:cs typeface="-apple-system" pitchFamily="34" charset="-120"/>
+                <a:latin typeface="Aptos" pitchFamily="34" charset="0"/>
+                <a:ea typeface="Aptos" pitchFamily="34" charset="-122"/>
+                <a:cs typeface="Aptos" pitchFamily="34" charset="-120"/>
               </a:rPr>
               <a:t>{Leverans 2}</a:t>
             </a:r>
@@ -23681,9 +23681,9 @@
                 <a:solidFill>
                   <a:srgbClr val="1A1A1A"/>
                 </a:solidFill>
-                <a:latin typeface="-apple-system" pitchFamily="34" charset="0"/>
-                <a:ea typeface="-apple-system" pitchFamily="34" charset="-122"/>
-                <a:cs typeface="-apple-system" pitchFamily="34" charset="-120"/>
+                <a:latin typeface="Aptos" pitchFamily="34" charset="0"/>
+                <a:ea typeface="Aptos" pitchFamily="34" charset="-122"/>
+                <a:cs typeface="Aptos" pitchFamily="34" charset="-120"/>
               </a:rPr>
               <a:t>{Leverans 3}</a:t>
             </a:r>
@@ -23831,9 +23831,9 @@
                 <a:solidFill>
                   <a:srgbClr val="1A1A1A"/>
                 </a:solidFill>
-                <a:latin typeface="-apple-system" pitchFamily="34" charset="0"/>
-                <a:ea typeface="-apple-system" pitchFamily="34" charset="-122"/>
-                <a:cs typeface="-apple-system" pitchFamily="34" charset="-120"/>
+                <a:latin typeface="Aptos" pitchFamily="34" charset="0"/>
+                <a:ea typeface="Aptos" pitchFamily="34" charset="-122"/>
+                <a:cs typeface="Aptos" pitchFamily="34" charset="-120"/>
               </a:rPr>
               <a:t>{Beslut 1}</a:t>
             </a:r>
@@ -23875,9 +23875,9 @@
                 <a:solidFill>
                   <a:srgbClr val="1A1A1A"/>
                 </a:solidFill>
-                <a:latin typeface="-apple-system" pitchFamily="34" charset="0"/>
-                <a:ea typeface="-apple-system" pitchFamily="34" charset="-122"/>
-                <a:cs typeface="-apple-system" pitchFamily="34" charset="-120"/>
+                <a:latin typeface="Aptos" pitchFamily="34" charset="0"/>
+                <a:ea typeface="Aptos" pitchFamily="34" charset="-122"/>
+                <a:cs typeface="Aptos" pitchFamily="34" charset="-120"/>
               </a:rPr>
               <a:t>{Beslut 2}</a:t>
             </a:r>
@@ -23919,9 +23919,9 @@
                 <a:solidFill>
                   <a:srgbClr val="1A1A1A"/>
                 </a:solidFill>
-                <a:latin typeface="-apple-system" pitchFamily="34" charset="0"/>
-                <a:ea typeface="-apple-system" pitchFamily="34" charset="-122"/>
-                <a:cs typeface="-apple-system" pitchFamily="34" charset="-120"/>
+                <a:latin typeface="Aptos" pitchFamily="34" charset="0"/>
+                <a:ea typeface="Aptos" pitchFamily="34" charset="-122"/>
+                <a:cs typeface="Aptos" pitchFamily="34" charset="-120"/>
               </a:rPr>
               <a:t>{Go/no-go till nästa fas}</a:t>
             </a:r>
@@ -25062,9 +25062,9 @@
                 <a:solidFill>
                   <a:srgbClr val="4A4A4A"/>
                 </a:solidFill>
-                <a:latin typeface="-apple-system" pitchFamily="34" charset="0"/>
-                <a:ea typeface="-apple-system" pitchFamily="34" charset="-122"/>
-                <a:cs typeface="-apple-system" pitchFamily="34" charset="-120"/>
+                <a:latin typeface="Aptos" pitchFamily="34" charset="0"/>
+                <a:ea typeface="Aptos" pitchFamily="34" charset="-122"/>
+                <a:cs typeface="Aptos" pitchFamily="34" charset="-120"/>
               </a:rPr>
               <a:t>09 · GENOMFÖRANDE — FAS 3 AV 4</a:t>
             </a:r>
@@ -25133,9 +25133,9 @@
                 <a:solidFill>
                   <a:srgbClr val="2B5F5F"/>
                 </a:solidFill>
-                <a:latin typeface="-apple-system" pitchFamily="34" charset="0"/>
-                <a:ea typeface="-apple-system" pitchFamily="34" charset="-122"/>
-                <a:cs typeface="-apple-system" pitchFamily="34" charset="-120"/>
+                <a:latin typeface="Aptos" pitchFamily="34" charset="0"/>
+                <a:ea typeface="Aptos" pitchFamily="34" charset="-122"/>
+                <a:cs typeface="Aptos" pitchFamily="34" charset="-120"/>
               </a:rPr>
               <a:t>03</a:t>
             </a:r>
@@ -25218,9 +25218,9 @@
                 <a:solidFill>
                   <a:srgbClr val="1A1A1A"/>
                 </a:solidFill>
-                <a:latin typeface="-apple-system" pitchFamily="34" charset="0"/>
-                <a:ea typeface="-apple-system" pitchFamily="34" charset="-122"/>
-                <a:cs typeface="-apple-system" pitchFamily="34" charset="-120"/>
+                <a:latin typeface="Aptos" pitchFamily="34" charset="0"/>
+                <a:ea typeface="Aptos" pitchFamily="34" charset="-122"/>
+                <a:cs typeface="Aptos" pitchFamily="34" charset="-120"/>
               </a:rPr>
               <a:t>{Fas 3 — namn}</a:t>
             </a:r>
@@ -25382,9 +25382,9 @@
                 <a:solidFill>
                   <a:srgbClr val="1A1A1A"/>
                 </a:solidFill>
-                <a:latin typeface="-apple-system" pitchFamily="34" charset="0"/>
-                <a:ea typeface="-apple-system" pitchFamily="34" charset="-122"/>
-                <a:cs typeface="-apple-system" pitchFamily="34" charset="-120"/>
+                <a:latin typeface="Aptos" pitchFamily="34" charset="0"/>
+                <a:ea typeface="Aptos" pitchFamily="34" charset="-122"/>
+                <a:cs typeface="Aptos" pitchFamily="34" charset="-120"/>
               </a:rPr>
               <a:t>{Aktivitet 1}</a:t>
             </a:r>
@@ -25426,9 +25426,9 @@
                 <a:solidFill>
                   <a:srgbClr val="1A1A1A"/>
                 </a:solidFill>
-                <a:latin typeface="-apple-system" pitchFamily="34" charset="0"/>
-                <a:ea typeface="-apple-system" pitchFamily="34" charset="-122"/>
-                <a:cs typeface="-apple-system" pitchFamily="34" charset="-120"/>
+                <a:latin typeface="Aptos" pitchFamily="34" charset="0"/>
+                <a:ea typeface="Aptos" pitchFamily="34" charset="-122"/>
+                <a:cs typeface="Aptos" pitchFamily="34" charset="-120"/>
               </a:rPr>
               <a:t>{Aktivitet 2}</a:t>
             </a:r>
@@ -25470,9 +25470,9 @@
                 <a:solidFill>
                   <a:srgbClr val="1A1A1A"/>
                 </a:solidFill>
-                <a:latin typeface="-apple-system" pitchFamily="34" charset="0"/>
-                <a:ea typeface="-apple-system" pitchFamily="34" charset="-122"/>
-                <a:cs typeface="-apple-system" pitchFamily="34" charset="-120"/>
+                <a:latin typeface="Aptos" pitchFamily="34" charset="0"/>
+                <a:ea typeface="Aptos" pitchFamily="34" charset="-122"/>
+                <a:cs typeface="Aptos" pitchFamily="34" charset="-120"/>
               </a:rPr>
               <a:t>{Aktivitet 3}</a:t>
             </a:r>
@@ -25514,9 +25514,9 @@
                 <a:solidFill>
                   <a:srgbClr val="1A1A1A"/>
                 </a:solidFill>
-                <a:latin typeface="-apple-system" pitchFamily="34" charset="0"/>
-                <a:ea typeface="-apple-system" pitchFamily="34" charset="-122"/>
-                <a:cs typeface="-apple-system" pitchFamily="34" charset="-120"/>
+                <a:latin typeface="Aptos" pitchFamily="34" charset="0"/>
+                <a:ea typeface="Aptos" pitchFamily="34" charset="-122"/>
+                <a:cs typeface="Aptos" pitchFamily="34" charset="-120"/>
               </a:rPr>
               <a:t>{Aktivitet 4}</a:t>
             </a:r>
@@ -25637,9 +25637,9 @@
                 <a:solidFill>
                   <a:srgbClr val="1A1A1A"/>
                 </a:solidFill>
-                <a:latin typeface="-apple-system" pitchFamily="34" charset="0"/>
-                <a:ea typeface="-apple-system" pitchFamily="34" charset="-122"/>
-                <a:cs typeface="-apple-system" pitchFamily="34" charset="-120"/>
+                <a:latin typeface="Aptos" pitchFamily="34" charset="0"/>
+                <a:ea typeface="Aptos" pitchFamily="34" charset="-122"/>
+                <a:cs typeface="Aptos" pitchFamily="34" charset="-120"/>
               </a:rPr>
               <a:t>{Leverans 1}</a:t>
             </a:r>
@@ -25681,9 +25681,9 @@
                 <a:solidFill>
                   <a:srgbClr val="1A1A1A"/>
                 </a:solidFill>
-                <a:latin typeface="-apple-system" pitchFamily="34" charset="0"/>
-                <a:ea typeface="-apple-system" pitchFamily="34" charset="-122"/>
-                <a:cs typeface="-apple-system" pitchFamily="34" charset="-120"/>
+                <a:latin typeface="Aptos" pitchFamily="34" charset="0"/>
+                <a:ea typeface="Aptos" pitchFamily="34" charset="-122"/>
+                <a:cs typeface="Aptos" pitchFamily="34" charset="-120"/>
               </a:rPr>
               <a:t>{Leverans 2}</a:t>
             </a:r>
@@ -25725,9 +25725,9 @@
                 <a:solidFill>
                   <a:srgbClr val="1A1A1A"/>
                 </a:solidFill>
-                <a:latin typeface="-apple-system" pitchFamily="34" charset="0"/>
-                <a:ea typeface="-apple-system" pitchFamily="34" charset="-122"/>
-                <a:cs typeface="-apple-system" pitchFamily="34" charset="-120"/>
+                <a:latin typeface="Aptos" pitchFamily="34" charset="0"/>
+                <a:ea typeface="Aptos" pitchFamily="34" charset="-122"/>
+                <a:cs typeface="Aptos" pitchFamily="34" charset="-120"/>
               </a:rPr>
               <a:t>{Leverans 3}</a:t>
             </a:r>
@@ -25875,9 +25875,9 @@
                 <a:solidFill>
                   <a:srgbClr val="1A1A1A"/>
                 </a:solidFill>
-                <a:latin typeface="-apple-system" pitchFamily="34" charset="0"/>
-                <a:ea typeface="-apple-system" pitchFamily="34" charset="-122"/>
-                <a:cs typeface="-apple-system" pitchFamily="34" charset="-120"/>
+                <a:latin typeface="Aptos" pitchFamily="34" charset="0"/>
+                <a:ea typeface="Aptos" pitchFamily="34" charset="-122"/>
+                <a:cs typeface="Aptos" pitchFamily="34" charset="-120"/>
               </a:rPr>
               <a:t>{Beslut 1}</a:t>
             </a:r>
@@ -25919,9 +25919,9 @@
                 <a:solidFill>
                   <a:srgbClr val="1A1A1A"/>
                 </a:solidFill>
-                <a:latin typeface="-apple-system" pitchFamily="34" charset="0"/>
-                <a:ea typeface="-apple-system" pitchFamily="34" charset="-122"/>
-                <a:cs typeface="-apple-system" pitchFamily="34" charset="-120"/>
+                <a:latin typeface="Aptos" pitchFamily="34" charset="0"/>
+                <a:ea typeface="Aptos" pitchFamily="34" charset="-122"/>
+                <a:cs typeface="Aptos" pitchFamily="34" charset="-120"/>
               </a:rPr>
               <a:t>{Beslut 2}</a:t>
             </a:r>
@@ -25963,9 +25963,9 @@
                 <a:solidFill>
                   <a:srgbClr val="1A1A1A"/>
                 </a:solidFill>
-                <a:latin typeface="-apple-system" pitchFamily="34" charset="0"/>
-                <a:ea typeface="-apple-system" pitchFamily="34" charset="-122"/>
-                <a:cs typeface="-apple-system" pitchFamily="34" charset="-120"/>
+                <a:latin typeface="Aptos" pitchFamily="34" charset="0"/>
+                <a:ea typeface="Aptos" pitchFamily="34" charset="-122"/>
+                <a:cs typeface="Aptos" pitchFamily="34" charset="-120"/>
               </a:rPr>
               <a:t>{Go/no-go till nästa fas}</a:t>
             </a:r>

</xml_diff>